<commit_message>
docs: add technical report PDF
</commit_message>
<xml_diff>
--- a/music-recommendation-api/docs/Music_Recommendation_API.pptx
+++ b/music-recommendation-api/docs/Music_Recommendation_API.pptx
@@ -1,24 +1,24 @@
 
 <file path=ppt/presentation.xml><?xml version="1.0" encoding="utf-8"?>
-<p:presentation xmlns:a="http://schemas.openxmlformats.org/drawingml/2006/main" xmlns:r="http://schemas.openxmlformats.org/officeDocument/2006/relationships" xmlns:p="http://schemas.openxmlformats.org/presentationml/2006/main" saveSubsetFonts="1" autoCompressPictures="0">
+<p:presentation xmlns:a="http://schemas.openxmlformats.org/drawingml/2006/main" xmlns:r="http://schemas.openxmlformats.org/officeDocument/2006/relationships" xmlns:p="http://schemas.openxmlformats.org/presentationml/2006/main" autoCompressPictures="0">
   <p:sldMasterIdLst>
     <p:sldMasterId id="2147483648" r:id="rId1"/>
   </p:sldMasterIdLst>
+  <p:notesMasterIdLst>
+    <p:notesMasterId r:id="rId4"/>
+  </p:notesMasterIdLst>
   <p:sldIdLst>
-    <p:sldId id="256" r:id="rId2"/>
-    <p:sldId id="257" r:id="rId3"/>
-    <p:sldId id="258" r:id="rId4"/>
-    <p:sldId id="259" r:id="rId5"/>
-    <p:sldId id="260" r:id="rId6"/>
-    <p:sldId id="261" r:id="rId7"/>
-    <p:sldId id="262" r:id="rId8"/>
-    <p:sldId id="263" r:id="rId9"/>
-    <p:sldId id="264" r:id="rId10"/>
-    <p:sldId id="265" r:id="rId11"/>
+    <p:sldId id="256" r:id="rId3"/>
+    <p:sldId id="257" r:id="rId5"/>
+    <p:sldId id="258" r:id="rId6"/>
+    <p:sldId id="259" r:id="rId7"/>
+    <p:sldId id="260" r:id="rId8"/>
+    <p:sldId id="261" r:id="rId9"/>
+    <p:sldId id="262" r:id="rId10"/>
+    <p:sldId id="263" r:id="rId11"/>
+    <p:sldId id="264" r:id="rId12"/>
+    <p:sldId id="265" r:id="rId13"/>
   </p:sldIdLst>
-  <p:notesMasterIdLst>
-    <p:notesMasterId r:id="rId12"/>
-  </p:notesMasterIdLst>
   <p:sldSz cx="9144000" cy="5143500"/>
   <p:notesSz cx="5143500" cy="9144000"/>
   <p:defaultTextStyle>
@@ -198,7 +198,6 @@
           <a:p>
             <a:fld id="{5282F153-3F37-0F45-9E97-73ACFA13230C}" type="datetimeFigureOut">
               <a:rPr lang="en-US"/>
-              <a:t>7/23/19</a:t>
             </a:fld>
             <a:endParaRPr lang="en-US"/>
           </a:p>
@@ -265,6 +264,7 @@
               <a:rPr lang="en-US"/>
               <a:t>Click to edit Master text styles</a:t>
             </a:r>
+            <a:endParaRPr lang="en-US"/>
           </a:p>
           <a:p>
             <a:pPr lvl="1"/>
@@ -272,6 +272,7 @@
               <a:rPr lang="en-US"/>
               <a:t>Second level</a:t>
             </a:r>
+            <a:endParaRPr lang="en-US"/>
           </a:p>
           <a:p>
             <a:pPr lvl="2"/>
@@ -279,6 +280,7 @@
               <a:rPr lang="en-US"/>
               <a:t>Third level</a:t>
             </a:r>
+            <a:endParaRPr lang="en-US"/>
           </a:p>
           <a:p>
             <a:pPr lvl="3"/>
@@ -286,6 +288,7 @@
               <a:rPr lang="en-US"/>
               <a:t>Fourth level</a:t>
             </a:r>
+            <a:endParaRPr lang="en-US"/>
           </a:p>
           <a:p>
             <a:pPr lvl="4"/>
@@ -293,6 +296,7 @@
               <a:rPr lang="en-US"/>
               <a:t>Fifth level</a:t>
             </a:r>
+            <a:endParaRPr lang="en-US"/>
           </a:p>
         </p:txBody>
       </p:sp>
@@ -356,18 +360,12 @@
           <a:p>
             <a:fld id="{CE5E9CC1-C706-0F49-92D6-E571CC5EEA8F}" type="slidenum">
               <a:rPr lang="en-US"/>
-              <a:t>‹#›</a:t>
             </a:fld>
             <a:endParaRPr lang="en-US"/>
           </a:p>
         </p:txBody>
       </p:sp>
     </p:spTree>
-    <p:extLst>
-      <p:ext uri="{BB962C8B-B14F-4D97-AF65-F5344CB8AC3E}">
-        <p14:creationId xmlns:p14="http://schemas.microsoft.com/office/powerpoint/2010/main" val="1024086991"/>
-      </p:ext>
-    </p:extLst>
   </p:cSld>
   <p:clrMap bg1="lt1" tx1="dk1" bg2="lt2" tx2="dk2" accent1="accent1" accent2="accent2" accent3="accent3" accent4="accent4" accent5="accent5" accent6="accent6" hlink="hlink" folHlink="folHlink"/>
   <p:notesStyle>
@@ -509,10 +507,6 @@
           <a:bodyPr/>
           <a:lstStyle/>
           <a:p>
-            <a:r>
-              <a:rPr lang="en-US" dirty="0"/>
-              <a:t/>
-            </a:r>
             <a:endParaRPr lang="en-US" dirty="0"/>
           </a:p>
         </p:txBody>
@@ -534,18 +528,12 @@
           <a:p>
             <a:fld id="{F7021451-1387-4CA6-816F-3879F97B5CBC}" type="slidenum">
               <a:rPr lang="en-US"/>
-              <a:t>1</a:t>
             </a:fld>
             <a:endParaRPr lang="en-US"/>
           </a:p>
         </p:txBody>
       </p:sp>
     </p:spTree>
-    <p:extLst>
-      <p:ext uri="{BB962C8B-B14F-4D97-AF65-F5344CB8AC3E}">
-        <p14:creationId xmlns:p14="http://schemas.microsoft.com/office/powerpoint/2010/main" val="1024086991"/>
-      </p:ext>
-    </p:extLst>
   </p:cSld>
   <p:clrMapOvr>
     <a:masterClrMapping/>
@@ -597,10 +585,6 @@
           <a:bodyPr/>
           <a:lstStyle/>
           <a:p>
-            <a:r>
-              <a:rPr lang="en-US" dirty="0"/>
-              <a:t/>
-            </a:r>
             <a:endParaRPr lang="en-US" dirty="0"/>
           </a:p>
         </p:txBody>
@@ -622,18 +606,12 @@
           <a:p>
             <a:fld id="{F7021451-1387-4CA6-816F-3879F97B5CBC}" type="slidenum">
               <a:rPr lang="en-US"/>
-              <a:t>10</a:t>
             </a:fld>
             <a:endParaRPr lang="en-US"/>
           </a:p>
         </p:txBody>
       </p:sp>
     </p:spTree>
-    <p:extLst>
-      <p:ext uri="{BB962C8B-B14F-4D97-AF65-F5344CB8AC3E}">
-        <p14:creationId xmlns:p14="http://schemas.microsoft.com/office/powerpoint/2010/main" val="1024086991"/>
-      </p:ext>
-    </p:extLst>
   </p:cSld>
   <p:clrMapOvr>
     <a:masterClrMapping/>
@@ -685,10 +663,6 @@
           <a:bodyPr/>
           <a:lstStyle/>
           <a:p>
-            <a:r>
-              <a:rPr lang="en-US" dirty="0"/>
-              <a:t/>
-            </a:r>
             <a:endParaRPr lang="en-US" dirty="0"/>
           </a:p>
         </p:txBody>
@@ -710,18 +684,12 @@
           <a:p>
             <a:fld id="{F7021451-1387-4CA6-816F-3879F97B5CBC}" type="slidenum">
               <a:rPr lang="en-US"/>
-              <a:t>2</a:t>
             </a:fld>
             <a:endParaRPr lang="en-US"/>
           </a:p>
         </p:txBody>
       </p:sp>
     </p:spTree>
-    <p:extLst>
-      <p:ext uri="{BB962C8B-B14F-4D97-AF65-F5344CB8AC3E}">
-        <p14:creationId xmlns:p14="http://schemas.microsoft.com/office/powerpoint/2010/main" val="1024086991"/>
-      </p:ext>
-    </p:extLst>
   </p:cSld>
   <p:clrMapOvr>
     <a:masterClrMapping/>
@@ -773,10 +741,6 @@
           <a:bodyPr/>
           <a:lstStyle/>
           <a:p>
-            <a:r>
-              <a:rPr lang="en-US" dirty="0"/>
-              <a:t/>
-            </a:r>
             <a:endParaRPr lang="en-US" dirty="0"/>
           </a:p>
         </p:txBody>
@@ -798,18 +762,12 @@
           <a:p>
             <a:fld id="{F7021451-1387-4CA6-816F-3879F97B5CBC}" type="slidenum">
               <a:rPr lang="en-US"/>
-              <a:t>3</a:t>
             </a:fld>
             <a:endParaRPr lang="en-US"/>
           </a:p>
         </p:txBody>
       </p:sp>
     </p:spTree>
-    <p:extLst>
-      <p:ext uri="{BB962C8B-B14F-4D97-AF65-F5344CB8AC3E}">
-        <p14:creationId xmlns:p14="http://schemas.microsoft.com/office/powerpoint/2010/main" val="1024086991"/>
-      </p:ext>
-    </p:extLst>
   </p:cSld>
   <p:clrMapOvr>
     <a:masterClrMapping/>
@@ -861,10 +819,6 @@
           <a:bodyPr/>
           <a:lstStyle/>
           <a:p>
-            <a:r>
-              <a:rPr lang="en-US" dirty="0"/>
-              <a:t/>
-            </a:r>
             <a:endParaRPr lang="en-US" dirty="0"/>
           </a:p>
         </p:txBody>
@@ -886,18 +840,12 @@
           <a:p>
             <a:fld id="{F7021451-1387-4CA6-816F-3879F97B5CBC}" type="slidenum">
               <a:rPr lang="en-US"/>
-              <a:t>4</a:t>
             </a:fld>
             <a:endParaRPr lang="en-US"/>
           </a:p>
         </p:txBody>
       </p:sp>
     </p:spTree>
-    <p:extLst>
-      <p:ext uri="{BB962C8B-B14F-4D97-AF65-F5344CB8AC3E}">
-        <p14:creationId xmlns:p14="http://schemas.microsoft.com/office/powerpoint/2010/main" val="1024086991"/>
-      </p:ext>
-    </p:extLst>
   </p:cSld>
   <p:clrMapOvr>
     <a:masterClrMapping/>
@@ -949,10 +897,6 @@
           <a:bodyPr/>
           <a:lstStyle/>
           <a:p>
-            <a:r>
-              <a:rPr lang="en-US" dirty="0"/>
-              <a:t/>
-            </a:r>
             <a:endParaRPr lang="en-US" dirty="0"/>
           </a:p>
         </p:txBody>
@@ -974,18 +918,12 @@
           <a:p>
             <a:fld id="{F7021451-1387-4CA6-816F-3879F97B5CBC}" type="slidenum">
               <a:rPr lang="en-US"/>
-              <a:t>5</a:t>
             </a:fld>
             <a:endParaRPr lang="en-US"/>
           </a:p>
         </p:txBody>
       </p:sp>
     </p:spTree>
-    <p:extLst>
-      <p:ext uri="{BB962C8B-B14F-4D97-AF65-F5344CB8AC3E}">
-        <p14:creationId xmlns:p14="http://schemas.microsoft.com/office/powerpoint/2010/main" val="1024086991"/>
-      </p:ext>
-    </p:extLst>
   </p:cSld>
   <p:clrMapOvr>
     <a:masterClrMapping/>
@@ -1037,10 +975,6 @@
           <a:bodyPr/>
           <a:lstStyle/>
           <a:p>
-            <a:r>
-              <a:rPr lang="en-US" dirty="0"/>
-              <a:t/>
-            </a:r>
             <a:endParaRPr lang="en-US" dirty="0"/>
           </a:p>
         </p:txBody>
@@ -1062,18 +996,12 @@
           <a:p>
             <a:fld id="{F7021451-1387-4CA6-816F-3879F97B5CBC}" type="slidenum">
               <a:rPr lang="en-US"/>
-              <a:t>6</a:t>
             </a:fld>
             <a:endParaRPr lang="en-US"/>
           </a:p>
         </p:txBody>
       </p:sp>
     </p:spTree>
-    <p:extLst>
-      <p:ext uri="{BB962C8B-B14F-4D97-AF65-F5344CB8AC3E}">
-        <p14:creationId xmlns:p14="http://schemas.microsoft.com/office/powerpoint/2010/main" val="1024086991"/>
-      </p:ext>
-    </p:extLst>
   </p:cSld>
   <p:clrMapOvr>
     <a:masterClrMapping/>
@@ -1125,10 +1053,6 @@
           <a:bodyPr/>
           <a:lstStyle/>
           <a:p>
-            <a:r>
-              <a:rPr lang="en-US" dirty="0"/>
-              <a:t/>
-            </a:r>
             <a:endParaRPr lang="en-US" dirty="0"/>
           </a:p>
         </p:txBody>
@@ -1150,18 +1074,12 @@
           <a:p>
             <a:fld id="{F7021451-1387-4CA6-816F-3879F97B5CBC}" type="slidenum">
               <a:rPr lang="en-US"/>
-              <a:t>7</a:t>
             </a:fld>
             <a:endParaRPr lang="en-US"/>
           </a:p>
         </p:txBody>
       </p:sp>
     </p:spTree>
-    <p:extLst>
-      <p:ext uri="{BB962C8B-B14F-4D97-AF65-F5344CB8AC3E}">
-        <p14:creationId xmlns:p14="http://schemas.microsoft.com/office/powerpoint/2010/main" val="1024086991"/>
-      </p:ext>
-    </p:extLst>
   </p:cSld>
   <p:clrMapOvr>
     <a:masterClrMapping/>
@@ -1213,10 +1131,6 @@
           <a:bodyPr/>
           <a:lstStyle/>
           <a:p>
-            <a:r>
-              <a:rPr lang="en-US" dirty="0"/>
-              <a:t/>
-            </a:r>
             <a:endParaRPr lang="en-US" dirty="0"/>
           </a:p>
         </p:txBody>
@@ -1238,18 +1152,12 @@
           <a:p>
             <a:fld id="{F7021451-1387-4CA6-816F-3879F97B5CBC}" type="slidenum">
               <a:rPr lang="en-US"/>
-              <a:t>8</a:t>
             </a:fld>
             <a:endParaRPr lang="en-US"/>
           </a:p>
         </p:txBody>
       </p:sp>
     </p:spTree>
-    <p:extLst>
-      <p:ext uri="{BB962C8B-B14F-4D97-AF65-F5344CB8AC3E}">
-        <p14:creationId xmlns:p14="http://schemas.microsoft.com/office/powerpoint/2010/main" val="1024086991"/>
-      </p:ext>
-    </p:extLst>
   </p:cSld>
   <p:clrMapOvr>
     <a:masterClrMapping/>
@@ -1301,10 +1209,6 @@
           <a:bodyPr/>
           <a:lstStyle/>
           <a:p>
-            <a:r>
-              <a:rPr lang="en-US" dirty="0"/>
-              <a:t/>
-            </a:r>
             <a:endParaRPr lang="en-US" dirty="0"/>
           </a:p>
         </p:txBody>
@@ -1326,18 +1230,12 @@
           <a:p>
             <a:fld id="{F7021451-1387-4CA6-816F-3879F97B5CBC}" type="slidenum">
               <a:rPr lang="en-US"/>
-              <a:t>9</a:t>
             </a:fld>
             <a:endParaRPr lang="en-US"/>
           </a:p>
         </p:txBody>
       </p:sp>
     </p:spTree>
-    <p:extLst>
-      <p:ext uri="{BB962C8B-B14F-4D97-AF65-F5344CB8AC3E}">
-        <p14:creationId xmlns:p14="http://schemas.microsoft.com/office/powerpoint/2010/main" val="1024086991"/>
-      </p:ext>
-    </p:extLst>
   </p:cSld>
   <p:clrMapOvr>
     <a:masterClrMapping/>
@@ -1378,6 +1276,11 @@
 <file path=ppt/slideMasters/slideMaster1.xml><?xml version="1.0" encoding="utf-8"?>
 <p:sldMaster xmlns:a="http://schemas.openxmlformats.org/drawingml/2006/main" xmlns:r="http://schemas.openxmlformats.org/officeDocument/2006/relationships" xmlns:p="http://schemas.openxmlformats.org/presentationml/2006/main">
   <p:cSld>
+    <p:bg>
+      <p:bgRef idx="1001">
+        <a:schemeClr val="bg1"/>
+      </p:bgRef>
+    </p:bg>
     <p:spTree>
       <p:nvGrpSpPr>
         <p:cNvPr id="1" name=""/>
@@ -1421,7 +1324,7 @@
         <a:spcBef>
           <a:spcPct val="20000"/>
         </a:spcBef>
-        <a:buFont typeface="Arial" pitchFamily="34" charset="0"/>
+        <a:buFont typeface="Arial" panose="020B0604020202090204" pitchFamily="34" charset="0"/>
         <a:buChar char="•"/>
         <a:defRPr sz="3200" kern="1200">
           <a:solidFill>
@@ -1436,7 +1339,7 @@
         <a:spcBef>
           <a:spcPct val="20000"/>
         </a:spcBef>
-        <a:buFont typeface="Arial" pitchFamily="34" charset="0"/>
+        <a:buFont typeface="Arial" panose="020B0604020202090204" pitchFamily="34" charset="0"/>
         <a:buChar char="–"/>
         <a:defRPr sz="2800" kern="1200">
           <a:solidFill>
@@ -1451,7 +1354,7 @@
         <a:spcBef>
           <a:spcPct val="20000"/>
         </a:spcBef>
-        <a:buFont typeface="Arial" pitchFamily="34" charset="0"/>
+        <a:buFont typeface="Arial" panose="020B0604020202090204" pitchFamily="34" charset="0"/>
         <a:buChar char="•"/>
         <a:defRPr sz="2400" kern="1200">
           <a:solidFill>
@@ -1466,7 +1369,7 @@
         <a:spcBef>
           <a:spcPct val="20000"/>
         </a:spcBef>
-        <a:buFont typeface="Arial" pitchFamily="34" charset="0"/>
+        <a:buFont typeface="Arial" panose="020B0604020202090204" pitchFamily="34" charset="0"/>
         <a:buChar char="–"/>
         <a:defRPr sz="2000" kern="1200">
           <a:solidFill>
@@ -1481,7 +1384,7 @@
         <a:spcBef>
           <a:spcPct val="20000"/>
         </a:spcBef>
-        <a:buFont typeface="Arial" pitchFamily="34" charset="0"/>
+        <a:buFont typeface="Arial" panose="020B0604020202090204" pitchFamily="34" charset="0"/>
         <a:buChar char="»"/>
         <a:defRPr sz="2000" kern="1200">
           <a:solidFill>
@@ -1496,7 +1399,7 @@
         <a:spcBef>
           <a:spcPct val="20000"/>
         </a:spcBef>
-        <a:buFont typeface="Arial" pitchFamily="34" charset="0"/>
+        <a:buFont typeface="Arial" panose="020B0604020202090204" pitchFamily="34" charset="0"/>
         <a:buChar char="•"/>
         <a:defRPr sz="2000" kern="1200">
           <a:solidFill>
@@ -1511,7 +1414,7 @@
         <a:spcBef>
           <a:spcPct val="20000"/>
         </a:spcBef>
-        <a:buFont typeface="Arial" pitchFamily="34" charset="0"/>
+        <a:buFont typeface="Arial" panose="020B0604020202090204" pitchFamily="34" charset="0"/>
         <a:buChar char="•"/>
         <a:defRPr sz="2000" kern="1200">
           <a:solidFill>
@@ -1526,7 +1429,7 @@
         <a:spcBef>
           <a:spcPct val="20000"/>
         </a:spcBef>
-        <a:buFont typeface="Arial" pitchFamily="34" charset="0"/>
+        <a:buFont typeface="Arial" panose="020B0604020202090204" pitchFamily="34" charset="0"/>
         <a:buChar char="•"/>
         <a:defRPr sz="2000" kern="1200">
           <a:solidFill>
@@ -1541,7 +1444,7 @@
         <a:spcBef>
           <a:spcPct val="20000"/>
         </a:spcBef>
-        <a:buFont typeface="Arial" pitchFamily="34" charset="0"/>
+        <a:buFont typeface="Arial" panose="020B0604020202090204" pitchFamily="34" charset="0"/>
         <a:buChar char="•"/>
         <a:defRPr sz="2000" kern="1200">
           <a:solidFill>
@@ -1654,12 +1557,13 @@
 
 <file path=ppt/slides/slide1.xml><?xml version="1.0" encoding="utf-8"?>
 <p:sld xmlns:a="http://schemas.openxmlformats.org/drawingml/2006/main" xmlns:r="http://schemas.openxmlformats.org/officeDocument/2006/relationships" xmlns:p="http://schemas.openxmlformats.org/presentationml/2006/main">
-  <p:cSld name="Slide 1">
+  <p:cSld>
     <p:bg>
       <p:bgPr>
         <a:solidFill>
           <a:srgbClr val="0F1923"/>
         </a:solidFill>
+        <a:effectLst/>
       </p:bgPr>
     </p:bg>
     <p:spTree>
@@ -1741,13 +1645,12 @@
             <a:avLst/>
           </a:prstGeom>
           <a:noFill/>
-          <a:ln/>
         </p:spPr>
         <p:txBody>
           <a:bodyPr wrap="square" rtlCol="0" anchor="ctr"/>
           <a:lstStyle/>
           <a:p>
-            <a:pPr indent="0" marL="0">
+            <a:pPr marL="0" indent="0">
               <a:buNone/>
             </a:pPr>
             <a:r>
@@ -1780,13 +1683,12 @@
             <a:avLst/>
           </a:prstGeom>
           <a:noFill/>
-          <a:ln/>
         </p:spPr>
         <p:txBody>
           <a:bodyPr wrap="square" rtlCol="0" anchor="ctr"/>
           <a:lstStyle/>
           <a:p>
-            <a:pPr indent="0" marL="0">
+            <a:pPr marL="0" indent="0">
               <a:buNone/>
             </a:pPr>
             <a:r>
@@ -1819,13 +1721,12 @@
             <a:avLst/>
           </a:prstGeom>
           <a:noFill/>
-          <a:ln/>
         </p:spPr>
         <p:txBody>
           <a:bodyPr wrap="square" rtlCol="0" anchor="ctr"/>
           <a:lstStyle/>
           <a:p>
-            <a:pPr indent="0" marL="0">
+            <a:pPr marL="0" indent="0">
               <a:buNone/>
             </a:pPr>
             <a:r>
@@ -1858,13 +1759,12 @@
             <a:avLst/>
           </a:prstGeom>
           <a:noFill/>
-          <a:ln/>
         </p:spPr>
         <p:txBody>
           <a:bodyPr wrap="square" rtlCol="0" anchor="ctr"/>
           <a:lstStyle/>
           <a:p>
-            <a:pPr indent="0" marL="0">
+            <a:pPr marL="0" indent="0">
               <a:buNone/>
             </a:pPr>
             <a:r>
@@ -1892,12 +1792,13 @@
 
 <file path=ppt/slides/slide10.xml><?xml version="1.0" encoding="utf-8"?>
 <p:sld xmlns:a="http://schemas.openxmlformats.org/drawingml/2006/main" xmlns:r="http://schemas.openxmlformats.org/officeDocument/2006/relationships" xmlns:p="http://schemas.openxmlformats.org/presentationml/2006/main">
-  <p:cSld name="Slide 10">
+  <p:cSld>
     <p:bg>
       <p:bgPr>
         <a:solidFill>
           <a:srgbClr val="0F1923"/>
         </a:solidFill>
+        <a:effectLst/>
       </p:bgPr>
     </p:bg>
     <p:spTree>
@@ -1954,13 +1855,12 @@
             <a:avLst/>
           </a:prstGeom>
           <a:noFill/>
-          <a:ln/>
         </p:spPr>
         <p:txBody>
           <a:bodyPr wrap="square" rtlCol="0" anchor="ctr"/>
           <a:lstStyle/>
           <a:p>
-            <a:pPr indent="0" marL="0">
+            <a:pPr marL="0" indent="0">
               <a:buNone/>
             </a:pPr>
             <a:r>
@@ -2018,13 +1918,12 @@
             <a:avLst/>
           </a:prstGeom>
           <a:noFill/>
-          <a:ln/>
         </p:spPr>
         <p:txBody>
           <a:bodyPr wrap="square" lIns="0" tIns="0" rIns="0" bIns="0" rtlCol="0" anchor="ctr"/>
           <a:lstStyle/>
           <a:p>
-            <a:pPr indent="0" marL="0">
+            <a:pPr marL="0" indent="0">
               <a:buNone/>
             </a:pPr>
             <a:r>
@@ -2057,7 +1956,6 @@
             <a:avLst/>
           </a:prstGeom>
           <a:noFill/>
-          <a:ln/>
         </p:spPr>
         <p:txBody>
           <a:bodyPr wrap="square" rtlCol="0" anchor="ctr"/>
@@ -2158,13 +2056,12 @@
             <a:avLst/>
           </a:prstGeom>
           <a:noFill/>
-          <a:ln/>
         </p:spPr>
         <p:txBody>
           <a:bodyPr wrap="square" lIns="0" tIns="0" rIns="0" bIns="0" rtlCol="0" anchor="ctr"/>
           <a:lstStyle/>
           <a:p>
-            <a:pPr indent="0" marL="0">
+            <a:pPr marL="0" indent="0">
               <a:buNone/>
             </a:pPr>
             <a:r>
@@ -2197,7 +2094,6 @@
             <a:avLst/>
           </a:prstGeom>
           <a:noFill/>
-          <a:ln/>
         </p:spPr>
         <p:txBody>
           <a:bodyPr wrap="square" rtlCol="0" anchor="ctr"/>
@@ -2316,13 +2212,12 @@
             <a:avLst/>
           </a:prstGeom>
           <a:noFill/>
-          <a:ln/>
         </p:spPr>
         <p:txBody>
           <a:bodyPr wrap="square" lIns="0" tIns="0" rIns="0" bIns="0" rtlCol="0" anchor="ctr"/>
           <a:lstStyle/>
           <a:p>
-            <a:pPr indent="0" marL="0">
+            <a:pPr marL="0" indent="0">
               <a:buNone/>
             </a:pPr>
             <a:r>
@@ -2355,7 +2250,6 @@
             <a:avLst/>
           </a:prstGeom>
           <a:noFill/>
-          <a:ln/>
         </p:spPr>
         <p:txBody>
           <a:bodyPr wrap="square" rtlCol="0" anchor="ctr"/>
@@ -2435,12 +2329,13 @@
 
 <file path=ppt/slides/slide2.xml><?xml version="1.0" encoding="utf-8"?>
 <p:sld xmlns:a="http://schemas.openxmlformats.org/drawingml/2006/main" xmlns:r="http://schemas.openxmlformats.org/officeDocument/2006/relationships" xmlns:p="http://schemas.openxmlformats.org/presentationml/2006/main">
-  <p:cSld name="Slide 2">
+  <p:cSld>
     <p:bg>
       <p:bgPr>
         <a:solidFill>
           <a:srgbClr val="F4F6F8"/>
         </a:solidFill>
+        <a:effectLst/>
       </p:bgPr>
     </p:bg>
     <p:spTree>
@@ -2497,13 +2392,12 @@
             <a:avLst/>
           </a:prstGeom>
           <a:noFill/>
-          <a:ln/>
         </p:spPr>
         <p:txBody>
           <a:bodyPr wrap="square" rtlCol="0" anchor="ctr"/>
           <a:lstStyle/>
           <a:p>
-            <a:pPr indent="0" marL="0">
+            <a:pPr marL="0" indent="0">
               <a:buNone/>
             </a:pPr>
             <a:r>
@@ -2545,7 +2439,7 @@
             <a:prstDash val="solid"/>
           </a:ln>
           <a:effectLst>
-            <a:outerShdw sx="100000" sy="100000" kx="0" ky="0" algn="bl" rotWithShape="0" blurRad="76200" dist="25400" dir="8100000">
+            <a:outerShdw blurRad="76200" dist="25400" dir="8100000" algn="bl" rotWithShape="0">
               <a:srgbClr val="000000">
                 <a:alpha val="15000"/>
               </a:srgbClr>
@@ -2568,13 +2462,12 @@
             <a:avLst/>
           </a:prstGeom>
           <a:noFill/>
-          <a:ln/>
         </p:spPr>
         <p:txBody>
           <a:bodyPr wrap="square" rtlCol="0" anchor="ctr"/>
           <a:lstStyle/>
           <a:p>
-            <a:pPr algn="ctr" indent="0" marL="0">
+            <a:pPr marL="0" indent="0" algn="ctr">
               <a:buNone/>
             </a:pPr>
             <a:r>
@@ -2607,13 +2500,12 @@
             <a:avLst/>
           </a:prstGeom>
           <a:noFill/>
-          <a:ln/>
         </p:spPr>
         <p:txBody>
           <a:bodyPr wrap="square" rtlCol="0" anchor="ctr"/>
           <a:lstStyle/>
           <a:p>
-            <a:pPr algn="ctr" indent="0" marL="0">
+            <a:pPr marL="0" indent="0" algn="ctr">
               <a:buNone/>
             </a:pPr>
             <a:r>
@@ -2655,7 +2547,7 @@
             <a:prstDash val="solid"/>
           </a:ln>
           <a:effectLst>
-            <a:outerShdw sx="100000" sy="100000" kx="0" ky="0" algn="bl" rotWithShape="0" blurRad="76200" dist="25400" dir="8100000">
+            <a:outerShdw blurRad="76200" dist="25400" dir="8100000" algn="bl" rotWithShape="0">
               <a:srgbClr val="000000">
                 <a:alpha val="15000"/>
               </a:srgbClr>
@@ -2678,13 +2570,12 @@
             <a:avLst/>
           </a:prstGeom>
           <a:noFill/>
-          <a:ln/>
         </p:spPr>
         <p:txBody>
           <a:bodyPr wrap="square" rtlCol="0" anchor="ctr"/>
           <a:lstStyle/>
           <a:p>
-            <a:pPr algn="ctr" indent="0" marL="0">
+            <a:pPr marL="0" indent="0" algn="ctr">
               <a:buNone/>
             </a:pPr>
             <a:r>
@@ -2717,13 +2608,12 @@
             <a:avLst/>
           </a:prstGeom>
           <a:noFill/>
-          <a:ln/>
         </p:spPr>
         <p:txBody>
           <a:bodyPr wrap="square" rtlCol="0" anchor="ctr"/>
           <a:lstStyle/>
           <a:p>
-            <a:pPr algn="ctr" indent="0" marL="0">
+            <a:pPr marL="0" indent="0" algn="ctr">
               <a:buNone/>
             </a:pPr>
             <a:r>
@@ -2765,7 +2655,7 @@
             <a:prstDash val="solid"/>
           </a:ln>
           <a:effectLst>
-            <a:outerShdw sx="100000" sy="100000" kx="0" ky="0" algn="bl" rotWithShape="0" blurRad="76200" dist="25400" dir="8100000">
+            <a:outerShdw blurRad="76200" dist="25400" dir="8100000" algn="bl" rotWithShape="0">
               <a:srgbClr val="000000">
                 <a:alpha val="15000"/>
               </a:srgbClr>
@@ -2788,13 +2678,12 @@
             <a:avLst/>
           </a:prstGeom>
           <a:noFill/>
-          <a:ln/>
         </p:spPr>
         <p:txBody>
           <a:bodyPr wrap="square" rtlCol="0" anchor="ctr"/>
           <a:lstStyle/>
           <a:p>
-            <a:pPr algn="ctr" indent="0" marL="0">
+            <a:pPr marL="0" indent="0" algn="ctr">
               <a:buNone/>
             </a:pPr>
             <a:r>
@@ -2827,13 +2716,12 @@
             <a:avLst/>
           </a:prstGeom>
           <a:noFill/>
-          <a:ln/>
         </p:spPr>
         <p:txBody>
           <a:bodyPr wrap="square" rtlCol="0" anchor="ctr"/>
           <a:lstStyle/>
           <a:p>
-            <a:pPr algn="ctr" indent="0" marL="0">
+            <a:pPr marL="0" indent="0" algn="ctr">
               <a:buNone/>
             </a:pPr>
             <a:r>
@@ -2875,7 +2763,7 @@
             <a:prstDash val="solid"/>
           </a:ln>
           <a:effectLst>
-            <a:outerShdw sx="100000" sy="100000" kx="0" ky="0" algn="bl" rotWithShape="0" blurRad="76200" dist="25400" dir="8100000">
+            <a:outerShdw blurRad="76200" dist="25400" dir="8100000" algn="bl" rotWithShape="0">
               <a:srgbClr val="000000">
                 <a:alpha val="15000"/>
               </a:srgbClr>
@@ -2898,13 +2786,12 @@
             <a:avLst/>
           </a:prstGeom>
           <a:noFill/>
-          <a:ln/>
         </p:spPr>
         <p:txBody>
           <a:bodyPr wrap="square" rtlCol="0" anchor="ctr"/>
           <a:lstStyle/>
           <a:p>
-            <a:pPr algn="ctr" indent="0" marL="0">
+            <a:pPr marL="0" indent="0" algn="ctr">
               <a:buNone/>
             </a:pPr>
             <a:r>
@@ -2937,13 +2824,12 @@
             <a:avLst/>
           </a:prstGeom>
           <a:noFill/>
-          <a:ln/>
         </p:spPr>
         <p:txBody>
           <a:bodyPr wrap="square" rtlCol="0" anchor="ctr"/>
           <a:lstStyle/>
           <a:p>
-            <a:pPr algn="ctr" indent="0" marL="0">
+            <a:pPr marL="0" indent="0" algn="ctr">
               <a:buNone/>
             </a:pPr>
             <a:r>
@@ -2976,7 +2862,6 @@
             <a:avLst/>
           </a:prstGeom>
           <a:noFill/>
-          <a:ln/>
         </p:spPr>
         <p:txBody>
           <a:bodyPr wrap="square" rtlCol="0" anchor="ctr"/>
@@ -3077,12 +2962,13 @@
 
 <file path=ppt/slides/slide3.xml><?xml version="1.0" encoding="utf-8"?>
 <p:sld xmlns:a="http://schemas.openxmlformats.org/drawingml/2006/main" xmlns:r="http://schemas.openxmlformats.org/officeDocument/2006/relationships" xmlns:p="http://schemas.openxmlformats.org/presentationml/2006/main">
-  <p:cSld name="Slide 3">
+  <p:cSld>
     <p:bg>
       <p:bgPr>
         <a:solidFill>
           <a:srgbClr val="0F1923"/>
         </a:solidFill>
+        <a:effectLst/>
       </p:bgPr>
     </p:bg>
     <p:spTree>
@@ -3139,13 +3025,12 @@
             <a:avLst/>
           </a:prstGeom>
           <a:noFill/>
-          <a:ln/>
         </p:spPr>
         <p:txBody>
           <a:bodyPr wrap="square" rtlCol="0" anchor="ctr"/>
           <a:lstStyle/>
           <a:p>
-            <a:pPr indent="0" marL="0">
+            <a:pPr marL="0" indent="0">
               <a:buNone/>
             </a:pPr>
             <a:r>
@@ -3228,13 +3113,12 @@
             <a:avLst/>
           </a:prstGeom>
           <a:noFill/>
-          <a:ln/>
         </p:spPr>
         <p:txBody>
           <a:bodyPr wrap="square" lIns="0" tIns="0" rIns="0" bIns="0" rtlCol="0" anchor="ctr"/>
           <a:lstStyle/>
           <a:p>
-            <a:pPr indent="0" marL="0">
+            <a:pPr marL="0" indent="0">
               <a:buNone/>
             </a:pPr>
             <a:r>
@@ -3267,13 +3151,12 @@
             <a:avLst/>
           </a:prstGeom>
           <a:noFill/>
-          <a:ln/>
         </p:spPr>
         <p:txBody>
           <a:bodyPr wrap="square" lIns="0" tIns="0" rIns="0" bIns="0" rtlCol="0" anchor="ctr"/>
           <a:lstStyle/>
           <a:p>
-            <a:pPr indent="0" marL="0">
+            <a:pPr marL="0" indent="0">
               <a:buNone/>
             </a:pPr>
             <a:r>
@@ -3356,13 +3239,12 @@
             <a:avLst/>
           </a:prstGeom>
           <a:noFill/>
-          <a:ln/>
         </p:spPr>
         <p:txBody>
           <a:bodyPr wrap="square" lIns="0" tIns="0" rIns="0" bIns="0" rtlCol="0" anchor="ctr"/>
           <a:lstStyle/>
           <a:p>
-            <a:pPr indent="0" marL="0">
+            <a:pPr marL="0" indent="0">
               <a:buNone/>
             </a:pPr>
             <a:r>
@@ -3395,13 +3277,12 @@
             <a:avLst/>
           </a:prstGeom>
           <a:noFill/>
-          <a:ln/>
         </p:spPr>
         <p:txBody>
           <a:bodyPr wrap="square" lIns="0" tIns="0" rIns="0" bIns="0" rtlCol="0" anchor="ctr"/>
           <a:lstStyle/>
           <a:p>
-            <a:pPr indent="0" marL="0">
+            <a:pPr marL="0" indent="0">
               <a:buNone/>
             </a:pPr>
             <a:r>
@@ -3484,13 +3365,12 @@
             <a:avLst/>
           </a:prstGeom>
           <a:noFill/>
-          <a:ln/>
         </p:spPr>
         <p:txBody>
           <a:bodyPr wrap="square" lIns="0" tIns="0" rIns="0" bIns="0" rtlCol="0" anchor="ctr"/>
           <a:lstStyle/>
           <a:p>
-            <a:pPr indent="0" marL="0">
+            <a:pPr marL="0" indent="0">
               <a:buNone/>
             </a:pPr>
             <a:r>
@@ -3523,13 +3403,12 @@
             <a:avLst/>
           </a:prstGeom>
           <a:noFill/>
-          <a:ln/>
         </p:spPr>
         <p:txBody>
           <a:bodyPr wrap="square" lIns="0" tIns="0" rIns="0" bIns="0" rtlCol="0" anchor="ctr"/>
           <a:lstStyle/>
           <a:p>
-            <a:pPr indent="0" marL="0">
+            <a:pPr marL="0" indent="0">
               <a:buNone/>
             </a:pPr>
             <a:r>
@@ -3612,13 +3491,12 @@
             <a:avLst/>
           </a:prstGeom>
           <a:noFill/>
-          <a:ln/>
         </p:spPr>
         <p:txBody>
           <a:bodyPr wrap="square" lIns="0" tIns="0" rIns="0" bIns="0" rtlCol="0" anchor="ctr"/>
           <a:lstStyle/>
           <a:p>
-            <a:pPr indent="0" marL="0">
+            <a:pPr marL="0" indent="0">
               <a:buNone/>
             </a:pPr>
             <a:r>
@@ -3651,13 +3529,12 @@
             <a:avLst/>
           </a:prstGeom>
           <a:noFill/>
-          <a:ln/>
         </p:spPr>
         <p:txBody>
           <a:bodyPr wrap="square" lIns="0" tIns="0" rIns="0" bIns="0" rtlCol="0" anchor="ctr"/>
           <a:lstStyle/>
           <a:p>
-            <a:pPr indent="0" marL="0">
+            <a:pPr marL="0" indent="0">
               <a:buNone/>
             </a:pPr>
             <a:r>
@@ -3740,13 +3617,12 @@
             <a:avLst/>
           </a:prstGeom>
           <a:noFill/>
-          <a:ln/>
         </p:spPr>
         <p:txBody>
           <a:bodyPr wrap="square" lIns="0" tIns="0" rIns="0" bIns="0" rtlCol="0" anchor="ctr"/>
           <a:lstStyle/>
           <a:p>
-            <a:pPr indent="0" marL="0">
+            <a:pPr marL="0" indent="0">
               <a:buNone/>
             </a:pPr>
             <a:r>
@@ -3779,13 +3655,12 @@
             <a:avLst/>
           </a:prstGeom>
           <a:noFill/>
-          <a:ln/>
         </p:spPr>
         <p:txBody>
           <a:bodyPr wrap="square" lIns="0" tIns="0" rIns="0" bIns="0" rtlCol="0" anchor="ctr"/>
           <a:lstStyle/>
           <a:p>
-            <a:pPr indent="0" marL="0">
+            <a:pPr marL="0" indent="0">
               <a:buNone/>
             </a:pPr>
             <a:r>
@@ -3813,12 +3688,13 @@
 
 <file path=ppt/slides/slide4.xml><?xml version="1.0" encoding="utf-8"?>
 <p:sld xmlns:a="http://schemas.openxmlformats.org/drawingml/2006/main" xmlns:r="http://schemas.openxmlformats.org/officeDocument/2006/relationships" xmlns:p="http://schemas.openxmlformats.org/presentationml/2006/main">
-  <p:cSld name="Slide 4">
+  <p:cSld>
     <p:bg>
       <p:bgPr>
         <a:solidFill>
           <a:srgbClr val="F4F6F8"/>
         </a:solidFill>
+        <a:effectLst/>
       </p:bgPr>
     </p:bg>
     <p:spTree>
@@ -3875,13 +3751,12 @@
             <a:avLst/>
           </a:prstGeom>
           <a:noFill/>
-          <a:ln/>
         </p:spPr>
         <p:txBody>
           <a:bodyPr wrap="square" rtlCol="0" anchor="ctr"/>
           <a:lstStyle/>
           <a:p>
-            <a:pPr indent="0" marL="0">
+            <a:pPr marL="0" indent="0">
               <a:buNone/>
             </a:pPr>
             <a:r>
@@ -3939,13 +3814,12 @@
             <a:avLst/>
           </a:prstGeom>
           <a:noFill/>
-          <a:ln/>
         </p:spPr>
         <p:txBody>
           <a:bodyPr wrap="square" rtlCol="0" anchor="ctr"/>
           <a:lstStyle/>
           <a:p>
-            <a:pPr algn="ctr" indent="0" marL="0">
+            <a:pPr marL="0" indent="0" algn="ctr">
               <a:buNone/>
             </a:pPr>
             <a:r>
@@ -4026,13 +3900,12 @@
             <a:avLst/>
           </a:prstGeom>
           <a:noFill/>
-          <a:ln/>
         </p:spPr>
         <p:txBody>
           <a:bodyPr wrap="square" rtlCol="0" anchor="ctr"/>
           <a:lstStyle/>
           <a:p>
-            <a:pPr algn="ctr" indent="0" marL="0">
+            <a:pPr marL="0" indent="0" algn="ctr">
               <a:buNone/>
             </a:pPr>
             <a:r>
@@ -4113,13 +3986,12 @@
             <a:avLst/>
           </a:prstGeom>
           <a:noFill/>
-          <a:ln/>
         </p:spPr>
         <p:txBody>
           <a:bodyPr wrap="square" rtlCol="0" anchor="ctr"/>
           <a:lstStyle/>
           <a:p>
-            <a:pPr algn="ctr" indent="0" marL="0">
+            <a:pPr marL="0" indent="0" algn="ctr">
               <a:buNone/>
             </a:pPr>
             <a:r>
@@ -4200,13 +4072,12 @@
             <a:avLst/>
           </a:prstGeom>
           <a:noFill/>
-          <a:ln/>
         </p:spPr>
         <p:txBody>
           <a:bodyPr wrap="square" rtlCol="0" anchor="ctr"/>
           <a:lstStyle/>
           <a:p>
-            <a:pPr algn="ctr" indent="0" marL="0">
+            <a:pPr marL="0" indent="0" algn="ctr">
               <a:buNone/>
             </a:pPr>
             <a:r>
@@ -4287,13 +4158,12 @@
             <a:avLst/>
           </a:prstGeom>
           <a:noFill/>
-          <a:ln/>
         </p:spPr>
         <p:txBody>
           <a:bodyPr wrap="square" rtlCol="0" anchor="ctr"/>
           <a:lstStyle/>
           <a:p>
-            <a:pPr algn="ctr" indent="0" marL="0">
+            <a:pPr marL="0" indent="0" algn="ctr">
               <a:buNone/>
             </a:pPr>
             <a:r>
@@ -4374,13 +4244,12 @@
             <a:avLst/>
           </a:prstGeom>
           <a:noFill/>
-          <a:ln/>
         </p:spPr>
         <p:txBody>
           <a:bodyPr wrap="square" rtlCol="0" anchor="ctr"/>
           <a:lstStyle/>
           <a:p>
-            <a:pPr algn="ctr" indent="0" marL="0">
+            <a:pPr marL="0" indent="0" algn="ctr">
               <a:buNone/>
             </a:pPr>
             <a:r>
@@ -4438,13 +4307,12 @@
             <a:avLst/>
           </a:prstGeom>
           <a:noFill/>
-          <a:ln/>
         </p:spPr>
         <p:txBody>
           <a:bodyPr wrap="square" lIns="0" tIns="0" rIns="0" bIns="0" rtlCol="0" anchor="ctr"/>
           <a:lstStyle/>
           <a:p>
-            <a:pPr indent="0" marL="0">
+            <a:pPr marL="0" indent="0">
               <a:buNone/>
             </a:pPr>
             <a:r>
@@ -4477,13 +4345,12 @@
             <a:avLst/>
           </a:prstGeom>
           <a:noFill/>
-          <a:ln/>
         </p:spPr>
         <p:txBody>
           <a:bodyPr wrap="square" lIns="0" tIns="0" rIns="0" bIns="0" rtlCol="0" anchor="ctr"/>
           <a:lstStyle/>
           <a:p>
-            <a:pPr indent="0" marL="0">
+            <a:pPr marL="0" indent="0">
               <a:buNone/>
             </a:pPr>
             <a:r>
@@ -4541,13 +4408,12 @@
             <a:avLst/>
           </a:prstGeom>
           <a:noFill/>
-          <a:ln/>
         </p:spPr>
         <p:txBody>
           <a:bodyPr wrap="square" lIns="0" tIns="0" rIns="0" bIns="0" rtlCol="0" anchor="ctr"/>
           <a:lstStyle/>
           <a:p>
-            <a:pPr indent="0" marL="0">
+            <a:pPr marL="0" indent="0">
               <a:buNone/>
             </a:pPr>
             <a:r>
@@ -4580,13 +4446,12 @@
             <a:avLst/>
           </a:prstGeom>
           <a:noFill/>
-          <a:ln/>
         </p:spPr>
         <p:txBody>
           <a:bodyPr wrap="square" lIns="0" tIns="0" rIns="0" bIns="0" rtlCol="0" anchor="ctr"/>
           <a:lstStyle/>
           <a:p>
-            <a:pPr indent="0" marL="0">
+            <a:pPr marL="0" indent="0">
               <a:buNone/>
             </a:pPr>
             <a:r>
@@ -4644,13 +4509,12 @@
             <a:avLst/>
           </a:prstGeom>
           <a:noFill/>
-          <a:ln/>
         </p:spPr>
         <p:txBody>
           <a:bodyPr wrap="square" lIns="0" tIns="0" rIns="0" bIns="0" rtlCol="0" anchor="ctr"/>
           <a:lstStyle/>
           <a:p>
-            <a:pPr indent="0" marL="0">
+            <a:pPr marL="0" indent="0">
               <a:buNone/>
             </a:pPr>
             <a:r>
@@ -4683,13 +4547,12 @@
             <a:avLst/>
           </a:prstGeom>
           <a:noFill/>
-          <a:ln/>
         </p:spPr>
         <p:txBody>
           <a:bodyPr wrap="square" lIns="0" tIns="0" rIns="0" bIns="0" rtlCol="0" anchor="ctr"/>
           <a:lstStyle/>
           <a:p>
-            <a:pPr indent="0" marL="0">
+            <a:pPr marL="0" indent="0">
               <a:buNone/>
             </a:pPr>
             <a:r>
@@ -4747,13 +4610,12 @@
             <a:avLst/>
           </a:prstGeom>
           <a:noFill/>
-          <a:ln/>
         </p:spPr>
         <p:txBody>
           <a:bodyPr wrap="square" lIns="0" tIns="0" rIns="0" bIns="0" rtlCol="0" anchor="ctr"/>
           <a:lstStyle/>
           <a:p>
-            <a:pPr indent="0" marL="0">
+            <a:pPr marL="0" indent="0">
               <a:buNone/>
             </a:pPr>
             <a:r>
@@ -4786,13 +4648,12 @@
             <a:avLst/>
           </a:prstGeom>
           <a:noFill/>
-          <a:ln/>
         </p:spPr>
         <p:txBody>
           <a:bodyPr wrap="square" lIns="0" tIns="0" rIns="0" bIns="0" rtlCol="0" anchor="ctr"/>
           <a:lstStyle/>
           <a:p>
-            <a:pPr indent="0" marL="0">
+            <a:pPr marL="0" indent="0">
               <a:buNone/>
             </a:pPr>
             <a:r>
@@ -4850,13 +4711,12 @@
             <a:avLst/>
           </a:prstGeom>
           <a:noFill/>
-          <a:ln/>
         </p:spPr>
         <p:txBody>
           <a:bodyPr wrap="square" lIns="0" tIns="0" rIns="0" bIns="0" rtlCol="0" anchor="ctr"/>
           <a:lstStyle/>
           <a:p>
-            <a:pPr indent="0" marL="0">
+            <a:pPr marL="0" indent="0">
               <a:buNone/>
             </a:pPr>
             <a:r>
@@ -4889,13 +4749,12 @@
             <a:avLst/>
           </a:prstGeom>
           <a:noFill/>
-          <a:ln/>
         </p:spPr>
         <p:txBody>
           <a:bodyPr wrap="square" lIns="0" tIns="0" rIns="0" bIns="0" rtlCol="0" anchor="ctr"/>
           <a:lstStyle/>
           <a:p>
-            <a:pPr indent="0" marL="0">
+            <a:pPr marL="0" indent="0">
               <a:buNone/>
             </a:pPr>
             <a:r>
@@ -4923,12 +4782,13 @@
 
 <file path=ppt/slides/slide5.xml><?xml version="1.0" encoding="utf-8"?>
 <p:sld xmlns:a="http://schemas.openxmlformats.org/drawingml/2006/main" xmlns:r="http://schemas.openxmlformats.org/officeDocument/2006/relationships" xmlns:p="http://schemas.openxmlformats.org/presentationml/2006/main">
-  <p:cSld name="Slide 5">
+  <p:cSld>
     <p:bg>
       <p:bgPr>
         <a:solidFill>
           <a:srgbClr val="0F1923"/>
         </a:solidFill>
+        <a:effectLst/>
       </p:bgPr>
     </p:bg>
     <p:spTree>
@@ -4985,13 +4845,12 @@
             <a:avLst/>
           </a:prstGeom>
           <a:noFill/>
-          <a:ln/>
         </p:spPr>
         <p:txBody>
           <a:bodyPr wrap="square" rtlCol="0" anchor="ctr"/>
           <a:lstStyle/>
           <a:p>
-            <a:pPr indent="0" marL="0">
+            <a:pPr marL="0" indent="0">
               <a:buNone/>
             </a:pPr>
             <a:r>
@@ -5049,13 +4908,12 @@
             <a:avLst/>
           </a:prstGeom>
           <a:noFill/>
-          <a:ln/>
         </p:spPr>
         <p:txBody>
           <a:bodyPr wrap="square" lIns="0" tIns="0" rIns="0" bIns="0" rtlCol="0" anchor="ctr"/>
           <a:lstStyle/>
           <a:p>
-            <a:pPr indent="0" marL="0">
+            <a:pPr marL="0" indent="0">
               <a:buNone/>
             </a:pPr>
             <a:r>
@@ -5088,13 +4946,12 @@
             <a:avLst/>
           </a:prstGeom>
           <a:noFill/>
-          <a:ln/>
         </p:spPr>
         <p:txBody>
           <a:bodyPr wrap="square" lIns="0" tIns="0" rIns="0" bIns="0" rtlCol="0" anchor="ctr"/>
           <a:lstStyle/>
           <a:p>
-            <a:pPr indent="0" marL="0">
+            <a:pPr marL="0" indent="0">
               <a:buNone/>
             </a:pPr>
             <a:r>
@@ -5152,13 +5009,12 @@
             <a:avLst/>
           </a:prstGeom>
           <a:noFill/>
-          <a:ln/>
         </p:spPr>
         <p:txBody>
           <a:bodyPr wrap="square" rtlCol="0" anchor="ctr"/>
           <a:lstStyle/>
           <a:p>
-            <a:pPr algn="ctr" indent="0" marL="0">
+            <a:pPr marL="0" indent="0" algn="ctr">
               <a:buNone/>
             </a:pPr>
             <a:r>
@@ -5216,13 +5072,12 @@
             <a:avLst/>
           </a:prstGeom>
           <a:noFill/>
-          <a:ln/>
         </p:spPr>
         <p:txBody>
           <a:bodyPr wrap="square" rtlCol="0" anchor="ctr"/>
           <a:lstStyle/>
           <a:p>
-            <a:pPr algn="ctr" indent="0" marL="0">
+            <a:pPr marL="0" indent="0" algn="ctr">
               <a:buNone/>
             </a:pPr>
             <a:r>
@@ -5280,13 +5135,12 @@
             <a:avLst/>
           </a:prstGeom>
           <a:noFill/>
-          <a:ln/>
         </p:spPr>
         <p:txBody>
           <a:bodyPr wrap="square" rtlCol="0" anchor="ctr"/>
           <a:lstStyle/>
           <a:p>
-            <a:pPr algn="ctr" indent="0" marL="0">
+            <a:pPr marL="0" indent="0" algn="ctr">
               <a:buNone/>
             </a:pPr>
             <a:r>
@@ -5344,13 +5198,12 @@
             <a:avLst/>
           </a:prstGeom>
           <a:noFill/>
-          <a:ln/>
         </p:spPr>
         <p:txBody>
           <a:bodyPr wrap="square" rtlCol="0" anchor="ctr"/>
           <a:lstStyle/>
           <a:p>
-            <a:pPr algn="ctr" indent="0" marL="0">
+            <a:pPr marL="0" indent="0" algn="ctr">
               <a:buNone/>
             </a:pPr>
             <a:r>
@@ -5408,13 +5261,12 @@
             <a:avLst/>
           </a:prstGeom>
           <a:noFill/>
-          <a:ln/>
         </p:spPr>
         <p:txBody>
           <a:bodyPr wrap="square" rtlCol="0" anchor="ctr"/>
           <a:lstStyle/>
           <a:p>
-            <a:pPr algn="ctr" indent="0" marL="0">
+            <a:pPr marL="0" indent="0" algn="ctr">
               <a:buNone/>
             </a:pPr>
             <a:r>
@@ -5472,13 +5324,12 @@
             <a:avLst/>
           </a:prstGeom>
           <a:noFill/>
-          <a:ln/>
         </p:spPr>
         <p:txBody>
           <a:bodyPr wrap="square" rtlCol="0" anchor="ctr"/>
           <a:lstStyle/>
           <a:p>
-            <a:pPr algn="ctr" indent="0" marL="0">
+            <a:pPr marL="0" indent="0" algn="ctr">
               <a:buNone/>
             </a:pPr>
             <a:r>
@@ -5561,13 +5412,12 @@
             <a:avLst/>
           </a:prstGeom>
           <a:noFill/>
-          <a:ln/>
         </p:spPr>
         <p:txBody>
           <a:bodyPr wrap="square" rtlCol="0" anchor="ctr"/>
           <a:lstStyle/>
           <a:p>
-            <a:pPr algn="ctr" indent="0" marL="0">
+            <a:pPr marL="0" indent="0" algn="ctr">
               <a:buNone/>
             </a:pPr>
             <a:r>
@@ -5600,13 +5450,12 @@
             <a:avLst/>
           </a:prstGeom>
           <a:noFill/>
-          <a:ln/>
         </p:spPr>
         <p:txBody>
           <a:bodyPr wrap="square" rtlCol="0" anchor="ctr"/>
           <a:lstStyle/>
           <a:p>
-            <a:pPr algn="ctr" indent="0" marL="0">
+            <a:pPr marL="0" indent="0" algn="ctr">
               <a:buNone/>
             </a:pPr>
             <a:r>
@@ -5689,13 +5538,12 @@
             <a:avLst/>
           </a:prstGeom>
           <a:noFill/>
-          <a:ln/>
         </p:spPr>
         <p:txBody>
           <a:bodyPr wrap="square" rtlCol="0" anchor="ctr"/>
           <a:lstStyle/>
           <a:p>
-            <a:pPr algn="ctr" indent="0" marL="0">
+            <a:pPr marL="0" indent="0" algn="ctr">
               <a:buNone/>
             </a:pPr>
             <a:r>
@@ -5728,13 +5576,12 @@
             <a:avLst/>
           </a:prstGeom>
           <a:noFill/>
-          <a:ln/>
         </p:spPr>
         <p:txBody>
           <a:bodyPr wrap="square" rtlCol="0" anchor="ctr"/>
           <a:lstStyle/>
           <a:p>
-            <a:pPr algn="ctr" indent="0" marL="0">
+            <a:pPr marL="0" indent="0" algn="ctr">
               <a:buNone/>
             </a:pPr>
             <a:r>
@@ -5817,13 +5664,12 @@
             <a:avLst/>
           </a:prstGeom>
           <a:noFill/>
-          <a:ln/>
         </p:spPr>
         <p:txBody>
           <a:bodyPr wrap="square" rtlCol="0" anchor="ctr"/>
           <a:lstStyle/>
           <a:p>
-            <a:pPr algn="ctr" indent="0" marL="0">
+            <a:pPr marL="0" indent="0" algn="ctr">
               <a:buNone/>
             </a:pPr>
             <a:r>
@@ -5856,13 +5702,12 @@
             <a:avLst/>
           </a:prstGeom>
           <a:noFill/>
-          <a:ln/>
         </p:spPr>
         <p:txBody>
           <a:bodyPr wrap="square" rtlCol="0" anchor="ctr"/>
           <a:lstStyle/>
           <a:p>
-            <a:pPr algn="ctr" indent="0" marL="0">
+            <a:pPr marL="0" indent="0" algn="ctr">
               <a:buNone/>
             </a:pPr>
             <a:r>
@@ -5945,13 +5790,12 @@
             <a:avLst/>
           </a:prstGeom>
           <a:noFill/>
-          <a:ln/>
         </p:spPr>
         <p:txBody>
           <a:bodyPr wrap="square" rtlCol="0" anchor="ctr"/>
           <a:lstStyle/>
           <a:p>
-            <a:pPr algn="ctr" indent="0" marL="0">
+            <a:pPr marL="0" indent="0" algn="ctr">
               <a:buNone/>
             </a:pPr>
             <a:r>
@@ -5984,13 +5828,12 @@
             <a:avLst/>
           </a:prstGeom>
           <a:noFill/>
-          <a:ln/>
         </p:spPr>
         <p:txBody>
           <a:bodyPr wrap="square" rtlCol="0" anchor="ctr"/>
           <a:lstStyle/>
           <a:p>
-            <a:pPr algn="ctr" indent="0" marL="0">
+            <a:pPr marL="0" indent="0" algn="ctr">
               <a:buNone/>
             </a:pPr>
             <a:r>
@@ -6018,12 +5861,13 @@
 
 <file path=ppt/slides/slide6.xml><?xml version="1.0" encoding="utf-8"?>
 <p:sld xmlns:a="http://schemas.openxmlformats.org/drawingml/2006/main" xmlns:r="http://schemas.openxmlformats.org/officeDocument/2006/relationships" xmlns:p="http://schemas.openxmlformats.org/presentationml/2006/main">
-  <p:cSld name="Slide 6">
+  <p:cSld>
     <p:bg>
       <p:bgPr>
         <a:solidFill>
           <a:srgbClr val="F4F6F8"/>
         </a:solidFill>
+        <a:effectLst/>
       </p:bgPr>
     </p:bg>
     <p:spTree>
@@ -6080,13 +5924,12 @@
             <a:avLst/>
           </a:prstGeom>
           <a:noFill/>
-          <a:ln/>
         </p:spPr>
         <p:txBody>
           <a:bodyPr wrap="square" rtlCol="0" anchor="ctr"/>
           <a:lstStyle/>
           <a:p>
-            <a:pPr indent="0" marL="0">
+            <a:pPr marL="0" indent="0">
               <a:buNone/>
             </a:pPr>
             <a:r>
@@ -6144,13 +5987,12 @@
             <a:avLst/>
           </a:prstGeom>
           <a:noFill/>
-          <a:ln/>
         </p:spPr>
         <p:txBody>
           <a:bodyPr wrap="square" lIns="0" tIns="0" rIns="0" bIns="0" rtlCol="0" anchor="ctr"/>
           <a:lstStyle/>
           <a:p>
-            <a:pPr indent="0" marL="0">
+            <a:pPr marL="0" indent="0">
               <a:buNone/>
             </a:pPr>
             <a:r>
@@ -6208,13 +6050,12 @@
             <a:avLst/>
           </a:prstGeom>
           <a:noFill/>
-          <a:ln/>
         </p:spPr>
         <p:txBody>
           <a:bodyPr wrap="square" rtlCol="0" anchor="ctr"/>
           <a:lstStyle/>
           <a:p>
-            <a:pPr algn="ctr" indent="0" marL="0">
+            <a:pPr marL="0" indent="0" algn="ctr">
               <a:buNone/>
             </a:pPr>
             <a:r>
@@ -6272,13 +6113,12 @@
             <a:avLst/>
           </a:prstGeom>
           <a:noFill/>
-          <a:ln/>
         </p:spPr>
         <p:txBody>
           <a:bodyPr wrap="square" lIns="0" tIns="0" rIns="0" bIns="0" rtlCol="0" anchor="ctr"/>
           <a:lstStyle/>
           <a:p>
-            <a:pPr indent="0" marL="0">
+            <a:pPr marL="0" indent="0">
               <a:buNone/>
             </a:pPr>
             <a:r>
@@ -6336,13 +6176,12 @@
             <a:avLst/>
           </a:prstGeom>
           <a:noFill/>
-          <a:ln/>
         </p:spPr>
         <p:txBody>
           <a:bodyPr wrap="square" rtlCol="0" anchor="ctr"/>
           <a:lstStyle/>
           <a:p>
-            <a:pPr algn="ctr" indent="0" marL="0">
+            <a:pPr marL="0" indent="0" algn="ctr">
               <a:buNone/>
             </a:pPr>
             <a:r>
@@ -6400,13 +6239,12 @@
             <a:avLst/>
           </a:prstGeom>
           <a:noFill/>
-          <a:ln/>
         </p:spPr>
         <p:txBody>
           <a:bodyPr wrap="square" lIns="0" tIns="0" rIns="0" bIns="0" rtlCol="0" anchor="ctr"/>
           <a:lstStyle/>
           <a:p>
-            <a:pPr indent="0" marL="0">
+            <a:pPr marL="0" indent="0">
               <a:buNone/>
             </a:pPr>
             <a:r>
@@ -6464,13 +6302,12 @@
             <a:avLst/>
           </a:prstGeom>
           <a:noFill/>
-          <a:ln/>
         </p:spPr>
         <p:txBody>
           <a:bodyPr wrap="square" rtlCol="0" anchor="ctr"/>
           <a:lstStyle/>
           <a:p>
-            <a:pPr algn="ctr" indent="0" marL="0">
+            <a:pPr marL="0" indent="0" algn="ctr">
               <a:buNone/>
             </a:pPr>
             <a:r>
@@ -6528,13 +6365,12 @@
             <a:avLst/>
           </a:prstGeom>
           <a:noFill/>
-          <a:ln/>
         </p:spPr>
         <p:txBody>
           <a:bodyPr wrap="square" lIns="0" tIns="0" rIns="0" bIns="0" rtlCol="0" anchor="ctr"/>
           <a:lstStyle/>
           <a:p>
-            <a:pPr indent="0" marL="0">
+            <a:pPr marL="0" indent="0">
               <a:buNone/>
             </a:pPr>
             <a:r>
@@ -6592,13 +6428,12 @@
             <a:avLst/>
           </a:prstGeom>
           <a:noFill/>
-          <a:ln/>
         </p:spPr>
         <p:txBody>
           <a:bodyPr wrap="square" rtlCol="0" anchor="ctr"/>
           <a:lstStyle/>
           <a:p>
-            <a:pPr algn="ctr" indent="0" marL="0">
+            <a:pPr marL="0" indent="0" algn="ctr">
               <a:buNone/>
             </a:pPr>
             <a:r>
@@ -6656,13 +6491,12 @@
             <a:avLst/>
           </a:prstGeom>
           <a:noFill/>
-          <a:ln/>
         </p:spPr>
         <p:txBody>
           <a:bodyPr wrap="square" lIns="0" tIns="0" rIns="0" bIns="0" rtlCol="0" anchor="ctr"/>
           <a:lstStyle/>
           <a:p>
-            <a:pPr indent="0" marL="0">
+            <a:pPr marL="0" indent="0">
               <a:buNone/>
             </a:pPr>
             <a:r>
@@ -6720,13 +6554,12 @@
             <a:avLst/>
           </a:prstGeom>
           <a:noFill/>
-          <a:ln/>
         </p:spPr>
         <p:txBody>
           <a:bodyPr wrap="square" rtlCol="0" anchor="ctr"/>
           <a:lstStyle/>
           <a:p>
-            <a:pPr algn="ctr" indent="0" marL="0">
+            <a:pPr marL="0" indent="0" algn="ctr">
               <a:buNone/>
             </a:pPr>
             <a:r>
@@ -6784,13 +6617,12 @@
             <a:avLst/>
           </a:prstGeom>
           <a:noFill/>
-          <a:ln/>
         </p:spPr>
         <p:txBody>
           <a:bodyPr wrap="square" lIns="0" tIns="0" rIns="0" bIns="0" rtlCol="0" anchor="ctr"/>
           <a:lstStyle/>
           <a:p>
-            <a:pPr indent="0" marL="0">
+            <a:pPr marL="0" indent="0">
               <a:buNone/>
             </a:pPr>
             <a:r>
@@ -6818,12 +6650,13 @@
 
 <file path=ppt/slides/slide7.xml><?xml version="1.0" encoding="utf-8"?>
 <p:sld xmlns:a="http://schemas.openxmlformats.org/drawingml/2006/main" xmlns:r="http://schemas.openxmlformats.org/officeDocument/2006/relationships" xmlns:p="http://schemas.openxmlformats.org/presentationml/2006/main">
-  <p:cSld name="Slide 7">
+  <p:cSld>
     <p:bg>
       <p:bgPr>
         <a:solidFill>
           <a:srgbClr val="0F1923"/>
         </a:solidFill>
+        <a:effectLst/>
       </p:bgPr>
     </p:bg>
     <p:spTree>
@@ -6880,13 +6713,12 @@
             <a:avLst/>
           </a:prstGeom>
           <a:noFill/>
-          <a:ln/>
         </p:spPr>
         <p:txBody>
           <a:bodyPr wrap="square" rtlCol="0" anchor="ctr"/>
           <a:lstStyle/>
           <a:p>
-            <a:pPr indent="0" marL="0">
+            <a:pPr marL="0" indent="0">
               <a:buNone/>
             </a:pPr>
             <a:r>
@@ -6944,13 +6776,12 @@
             <a:avLst/>
           </a:prstGeom>
           <a:noFill/>
-          <a:ln/>
         </p:spPr>
         <p:txBody>
           <a:bodyPr wrap="square" lIns="0" tIns="0" rIns="0" bIns="0" rtlCol="0" anchor="ctr"/>
           <a:lstStyle/>
           <a:p>
-            <a:pPr indent="0" marL="0">
+            <a:pPr marL="0" indent="0">
               <a:buNone/>
             </a:pPr>
             <a:r>
@@ -7033,13 +6864,12 @@
             <a:avLst/>
           </a:prstGeom>
           <a:noFill/>
-          <a:ln/>
         </p:spPr>
         <p:txBody>
           <a:bodyPr wrap="square" lIns="0" tIns="0" rIns="0" bIns="0" rtlCol="0" anchor="ctr"/>
           <a:lstStyle/>
           <a:p>
-            <a:pPr indent="0" marL="0">
+            <a:pPr marL="0" indent="0">
               <a:buNone/>
             </a:pPr>
             <a:r>
@@ -7072,13 +6902,12 @@
             <a:avLst/>
           </a:prstGeom>
           <a:noFill/>
-          <a:ln/>
         </p:spPr>
         <p:txBody>
           <a:bodyPr wrap="square" lIns="0" tIns="0" rIns="0" bIns="0" rtlCol="0" anchor="ctr"/>
           <a:lstStyle/>
           <a:p>
-            <a:pPr indent="0" marL="0">
+            <a:pPr marL="0" indent="0">
               <a:buNone/>
             </a:pPr>
             <a:r>
@@ -7161,13 +6990,12 @@
             <a:avLst/>
           </a:prstGeom>
           <a:noFill/>
-          <a:ln/>
         </p:spPr>
         <p:txBody>
           <a:bodyPr wrap="square" lIns="0" tIns="0" rIns="0" bIns="0" rtlCol="0" anchor="ctr"/>
           <a:lstStyle/>
           <a:p>
-            <a:pPr indent="0" marL="0">
+            <a:pPr marL="0" indent="0">
               <a:buNone/>
             </a:pPr>
             <a:r>
@@ -7200,13 +7028,12 @@
             <a:avLst/>
           </a:prstGeom>
           <a:noFill/>
-          <a:ln/>
         </p:spPr>
         <p:txBody>
           <a:bodyPr wrap="square" lIns="0" tIns="0" rIns="0" bIns="0" rtlCol="0" anchor="ctr"/>
           <a:lstStyle/>
           <a:p>
-            <a:pPr indent="0" marL="0">
+            <a:pPr marL="0" indent="0">
               <a:buNone/>
             </a:pPr>
             <a:r>
@@ -7289,13 +7116,12 @@
             <a:avLst/>
           </a:prstGeom>
           <a:noFill/>
-          <a:ln/>
         </p:spPr>
         <p:txBody>
           <a:bodyPr wrap="square" lIns="0" tIns="0" rIns="0" bIns="0" rtlCol="0" anchor="ctr"/>
           <a:lstStyle/>
           <a:p>
-            <a:pPr indent="0" marL="0">
+            <a:pPr marL="0" indent="0">
               <a:buNone/>
             </a:pPr>
             <a:r>
@@ -7328,13 +7154,12 @@
             <a:avLst/>
           </a:prstGeom>
           <a:noFill/>
-          <a:ln/>
         </p:spPr>
         <p:txBody>
           <a:bodyPr wrap="square" lIns="0" tIns="0" rIns="0" bIns="0" rtlCol="0" anchor="ctr"/>
           <a:lstStyle/>
           <a:p>
-            <a:pPr indent="0" marL="0">
+            <a:pPr marL="0" indent="0">
               <a:buNone/>
             </a:pPr>
             <a:r>
@@ -7417,13 +7242,12 @@
             <a:avLst/>
           </a:prstGeom>
           <a:noFill/>
-          <a:ln/>
         </p:spPr>
         <p:txBody>
           <a:bodyPr wrap="square" lIns="0" tIns="0" rIns="0" bIns="0" rtlCol="0" anchor="ctr"/>
           <a:lstStyle/>
           <a:p>
-            <a:pPr indent="0" marL="0">
+            <a:pPr marL="0" indent="0">
               <a:buNone/>
             </a:pPr>
             <a:r>
@@ -7456,13 +7280,12 @@
             <a:avLst/>
           </a:prstGeom>
           <a:noFill/>
-          <a:ln/>
         </p:spPr>
         <p:txBody>
           <a:bodyPr wrap="square" lIns="0" tIns="0" rIns="0" bIns="0" rtlCol="0" anchor="ctr"/>
           <a:lstStyle/>
           <a:p>
-            <a:pPr indent="0" marL="0">
+            <a:pPr marL="0" indent="0">
               <a:buNone/>
             </a:pPr>
             <a:r>
@@ -7545,13 +7368,12 @@
             <a:avLst/>
           </a:prstGeom>
           <a:noFill/>
-          <a:ln/>
         </p:spPr>
         <p:txBody>
           <a:bodyPr wrap="square" lIns="0" tIns="0" rIns="0" bIns="0" rtlCol="0" anchor="ctr"/>
           <a:lstStyle/>
           <a:p>
-            <a:pPr indent="0" marL="0">
+            <a:pPr marL="0" indent="0">
               <a:buNone/>
             </a:pPr>
             <a:r>
@@ -7584,13 +7406,12 @@
             <a:avLst/>
           </a:prstGeom>
           <a:noFill/>
-          <a:ln/>
         </p:spPr>
         <p:txBody>
           <a:bodyPr wrap="square" lIns="0" tIns="0" rIns="0" bIns="0" rtlCol="0" anchor="ctr"/>
           <a:lstStyle/>
           <a:p>
-            <a:pPr indent="0" marL="0">
+            <a:pPr marL="0" indent="0">
               <a:buNone/>
             </a:pPr>
             <a:r>
@@ -7618,12 +7439,13 @@
 
 <file path=ppt/slides/slide8.xml><?xml version="1.0" encoding="utf-8"?>
 <p:sld xmlns:a="http://schemas.openxmlformats.org/drawingml/2006/main" xmlns:r="http://schemas.openxmlformats.org/officeDocument/2006/relationships" xmlns:p="http://schemas.openxmlformats.org/presentationml/2006/main">
-  <p:cSld name="Slide 8">
+  <p:cSld>
     <p:bg>
       <p:bgPr>
         <a:solidFill>
           <a:srgbClr val="F4F6F8"/>
         </a:solidFill>
+        <a:effectLst/>
       </p:bgPr>
     </p:bg>
     <p:spTree>
@@ -7680,19 +7502,18 @@
             <a:avLst/>
           </a:prstGeom>
           <a:noFill/>
-          <a:ln/>
         </p:spPr>
         <p:txBody>
           <a:bodyPr wrap="square" rtlCol="0" anchor="ctr"/>
           <a:lstStyle/>
           <a:p>
-            <a:pPr indent="0" marL="0">
+            <a:pPr marL="0" indent="0">
               <a:buNone/>
             </a:pPr>
             <a:r>
               <a:rPr lang="en-US" sz="2400" b="1" dirty="0">
                 <a:solidFill>
-                  <a:srgbClr val="FFFFFF"/>
+                  <a:schemeClr val="bg1"/>
                 </a:solidFill>
                 <a:latin typeface="Calibri" pitchFamily="34" charset="0"/>
                 <a:ea typeface="Calibri" pitchFamily="34" charset="-122"/>
@@ -7700,7 +7521,14 @@
               </a:rPr>
               <a:t>Version Control</a:t>
             </a:r>
-            <a:endParaRPr lang="en-US" sz="2400" dirty="0"/>
+            <a:endParaRPr lang="en-US" sz="2400" b="1" dirty="0">
+              <a:solidFill>
+                <a:schemeClr val="bg1"/>
+              </a:solidFill>
+              <a:latin typeface="Calibri" pitchFamily="34" charset="0"/>
+              <a:ea typeface="Calibri" pitchFamily="34" charset="-122"/>
+              <a:cs typeface="Calibri" pitchFamily="34" charset="-120"/>
+            </a:endParaRPr>
           </a:p>
         </p:txBody>
       </p:sp>
@@ -7744,19 +7572,18 @@
             <a:avLst/>
           </a:prstGeom>
           <a:noFill/>
-          <a:ln/>
         </p:spPr>
         <p:txBody>
           <a:bodyPr wrap="square" lIns="0" tIns="0" rIns="0" bIns="0" rtlCol="0" anchor="ctr"/>
           <a:lstStyle/>
           <a:p>
-            <a:pPr indent="0" marL="0">
+            <a:pPr marL="0" indent="0">
               <a:buNone/>
             </a:pPr>
             <a:r>
               <a:rPr lang="en-US" sz="1300" dirty="0">
                 <a:solidFill>
-                  <a:srgbClr val="1DB954"/>
+                  <a:schemeClr val="bg1"/>
                 </a:solidFill>
                 <a:latin typeface="Consolas" pitchFamily="34" charset="0"/>
                 <a:ea typeface="Consolas" pitchFamily="34" charset="-122"/>
@@ -7764,7 +7591,14 @@
               </a:rPr>
               <a:t>github.com/sc22cz/music-recommendation-api</a:t>
             </a:r>
-            <a:endParaRPr lang="en-US" sz="1300" dirty="0"/>
+            <a:endParaRPr lang="en-US" sz="1300" dirty="0">
+              <a:solidFill>
+                <a:schemeClr val="bg1"/>
+              </a:solidFill>
+              <a:latin typeface="Consolas" pitchFamily="34" charset="0"/>
+              <a:ea typeface="Consolas" pitchFamily="34" charset="-122"/>
+              <a:cs typeface="Consolas" pitchFamily="34" charset="-120"/>
+            </a:endParaRPr>
           </a:p>
         </p:txBody>
       </p:sp>
@@ -7833,19 +7667,18 @@
             <a:avLst/>
           </a:prstGeom>
           <a:noFill/>
-          <a:ln/>
         </p:spPr>
         <p:txBody>
           <a:bodyPr wrap="square" lIns="0" tIns="0" rIns="0" bIns="0" rtlCol="0" anchor="ctr"/>
           <a:lstStyle/>
           <a:p>
-            <a:pPr indent="0" marL="0">
+            <a:pPr marL="0" indent="0">
               <a:buNone/>
             </a:pPr>
             <a:r>
               <a:rPr lang="en-US" sz="1000" dirty="0">
                 <a:solidFill>
-                  <a:srgbClr val="1A2332"/>
+                  <a:schemeClr val="bg1"/>
                 </a:solidFill>
                 <a:latin typeface="Consolas" pitchFamily="34" charset="0"/>
                 <a:ea typeface="Consolas" pitchFamily="34" charset="-122"/>
@@ -7853,7 +7686,14 @@
               </a:rPr>
               <a:t>feat: initial project structure and dependencies</a:t>
             </a:r>
-            <a:endParaRPr lang="en-US" sz="1000" dirty="0"/>
+            <a:endParaRPr lang="en-US" sz="1000" dirty="0">
+              <a:solidFill>
+                <a:schemeClr val="bg1"/>
+              </a:solidFill>
+              <a:latin typeface="Consolas" pitchFamily="34" charset="0"/>
+              <a:ea typeface="Consolas" pitchFamily="34" charset="-122"/>
+              <a:cs typeface="Consolas" pitchFamily="34" charset="-120"/>
+            </a:endParaRPr>
           </a:p>
         </p:txBody>
       </p:sp>
@@ -7922,19 +7762,18 @@
             <a:avLst/>
           </a:prstGeom>
           <a:noFill/>
-          <a:ln/>
         </p:spPr>
         <p:txBody>
           <a:bodyPr wrap="square" lIns="0" tIns="0" rIns="0" bIns="0" rtlCol="0" anchor="ctr"/>
           <a:lstStyle/>
           <a:p>
-            <a:pPr indent="0" marL="0">
+            <a:pPr marL="0" indent="0">
               <a:buNone/>
             </a:pPr>
             <a:r>
               <a:rPr lang="en-US" sz="1000" dirty="0">
                 <a:solidFill>
-                  <a:srgbClr val="1A2332"/>
+                  <a:schemeClr val="bg1"/>
                 </a:solidFill>
                 <a:latin typeface="Consolas" pitchFamily="34" charset="0"/>
                 <a:ea typeface="Consolas" pitchFamily="34" charset="-122"/>
@@ -7942,7 +7781,14 @@
               </a:rPr>
               <a:t>feat: add SQLAlchemy models for Song, Artist, User, Rating</a:t>
             </a:r>
-            <a:endParaRPr lang="en-US" sz="1000" dirty="0"/>
+            <a:endParaRPr lang="en-US" sz="1000" dirty="0">
+              <a:solidFill>
+                <a:schemeClr val="bg1"/>
+              </a:solidFill>
+              <a:latin typeface="Consolas" pitchFamily="34" charset="0"/>
+              <a:ea typeface="Consolas" pitchFamily="34" charset="-122"/>
+              <a:cs typeface="Consolas" pitchFamily="34" charset="-120"/>
+            </a:endParaRPr>
           </a:p>
         </p:txBody>
       </p:sp>
@@ -8011,19 +7857,18 @@
             <a:avLst/>
           </a:prstGeom>
           <a:noFill/>
-          <a:ln/>
         </p:spPr>
         <p:txBody>
           <a:bodyPr wrap="square" lIns="0" tIns="0" rIns="0" bIns="0" rtlCol="0" anchor="ctr"/>
           <a:lstStyle/>
           <a:p>
-            <a:pPr indent="0" marL="0">
+            <a:pPr marL="0" indent="0">
               <a:buNone/>
             </a:pPr>
             <a:r>
               <a:rPr lang="en-US" sz="1000" dirty="0">
                 <a:solidFill>
-                  <a:srgbClr val="1A2332"/>
+                  <a:schemeClr val="bg1"/>
                 </a:solidFill>
                 <a:latin typeface="Consolas" pitchFamily="34" charset="0"/>
                 <a:ea typeface="Consolas" pitchFamily="34" charset="-122"/>
@@ -8031,7 +7876,14 @@
               </a:rPr>
               <a:t>feat: add CRUD endpoints for songs and artists</a:t>
             </a:r>
-            <a:endParaRPr lang="en-US" sz="1000" dirty="0"/>
+            <a:endParaRPr lang="en-US" sz="1000" dirty="0">
+              <a:solidFill>
+                <a:schemeClr val="bg1"/>
+              </a:solidFill>
+              <a:latin typeface="Consolas" pitchFamily="34" charset="0"/>
+              <a:ea typeface="Consolas" pitchFamily="34" charset="-122"/>
+              <a:cs typeface="Consolas" pitchFamily="34" charset="-120"/>
+            </a:endParaRPr>
           </a:p>
         </p:txBody>
       </p:sp>
@@ -8100,19 +7952,18 @@
             <a:avLst/>
           </a:prstGeom>
           <a:noFill/>
-          <a:ln/>
         </p:spPr>
         <p:txBody>
           <a:bodyPr wrap="square" lIns="0" tIns="0" rIns="0" bIns="0" rtlCol="0" anchor="ctr"/>
           <a:lstStyle/>
           <a:p>
-            <a:pPr indent="0" marL="0">
+            <a:pPr marL="0" indent="0">
               <a:buNone/>
             </a:pPr>
             <a:r>
               <a:rPr lang="en-US" sz="1000" dirty="0">
                 <a:solidFill>
-                  <a:srgbClr val="1A2332"/>
+                  <a:schemeClr val="bg1"/>
                 </a:solidFill>
                 <a:latin typeface="Consolas" pitchFamily="34" charset="0"/>
                 <a:ea typeface="Consolas" pitchFamily="34" charset="-122"/>
@@ -8120,7 +7971,14 @@
               </a:rPr>
               <a:t>feat: add Spotify dataset import script with 4404 songs</a:t>
             </a:r>
-            <a:endParaRPr lang="en-US" sz="1000" dirty="0"/>
+            <a:endParaRPr lang="en-US" sz="1000" dirty="0">
+              <a:solidFill>
+                <a:schemeClr val="bg1"/>
+              </a:solidFill>
+              <a:latin typeface="Consolas" pitchFamily="34" charset="0"/>
+              <a:ea typeface="Consolas" pitchFamily="34" charset="-122"/>
+              <a:cs typeface="Consolas" pitchFamily="34" charset="-120"/>
+            </a:endParaRPr>
           </a:p>
         </p:txBody>
       </p:sp>
@@ -8189,19 +8047,18 @@
             <a:avLst/>
           </a:prstGeom>
           <a:noFill/>
-          <a:ln/>
         </p:spPr>
         <p:txBody>
           <a:bodyPr wrap="square" lIns="0" tIns="0" rIns="0" bIns="0" rtlCol="0" anchor="ctr"/>
           <a:lstStyle/>
           <a:p>
-            <a:pPr indent="0" marL="0">
+            <a:pPr marL="0" indent="0">
               <a:buNone/>
             </a:pPr>
             <a:r>
               <a:rPr lang="en-US" sz="1000" dirty="0">
                 <a:solidFill>
-                  <a:srgbClr val="1A2332"/>
+                  <a:schemeClr val="bg1"/>
                 </a:solidFill>
                 <a:latin typeface="Consolas" pitchFamily="34" charset="0"/>
                 <a:ea typeface="Consolas" pitchFamily="34" charset="-122"/>
@@ -8209,7 +8066,14 @@
               </a:rPr>
               <a:t>feat: add recommendation engine with mood, genre and similarity</a:t>
             </a:r>
-            <a:endParaRPr lang="en-US" sz="1000" dirty="0"/>
+            <a:endParaRPr lang="en-US" sz="1000" dirty="0">
+              <a:solidFill>
+                <a:schemeClr val="bg1"/>
+              </a:solidFill>
+              <a:latin typeface="Consolas" pitchFamily="34" charset="0"/>
+              <a:ea typeface="Consolas" pitchFamily="34" charset="-122"/>
+              <a:cs typeface="Consolas" pitchFamily="34" charset="-120"/>
+            </a:endParaRPr>
           </a:p>
         </p:txBody>
       </p:sp>
@@ -8278,19 +8142,18 @@
             <a:avLst/>
           </a:prstGeom>
           <a:noFill/>
-          <a:ln/>
         </p:spPr>
         <p:txBody>
           <a:bodyPr wrap="square" lIns="0" tIns="0" rIns="0" bIns="0" rtlCol="0" anchor="ctr"/>
           <a:lstStyle/>
           <a:p>
-            <a:pPr indent="0" marL="0">
+            <a:pPr marL="0" indent="0">
               <a:buNone/>
             </a:pPr>
             <a:r>
               <a:rPr lang="en-US" sz="1000" dirty="0">
                 <a:solidFill>
-                  <a:srgbClr val="1A2332"/>
+                  <a:schemeClr val="bg1"/>
                 </a:solidFill>
                 <a:latin typeface="Consolas" pitchFamily="34" charset="0"/>
                 <a:ea typeface="Consolas" pitchFamily="34" charset="-122"/>
@@ -8298,7 +8161,14 @@
               </a:rPr>
               <a:t>feat: add analytics endpoints for genre trends and mood distribution</a:t>
             </a:r>
-            <a:endParaRPr lang="en-US" sz="1000" dirty="0"/>
+            <a:endParaRPr lang="en-US" sz="1000" dirty="0">
+              <a:solidFill>
+                <a:schemeClr val="bg1"/>
+              </a:solidFill>
+              <a:latin typeface="Consolas" pitchFamily="34" charset="0"/>
+              <a:ea typeface="Consolas" pitchFamily="34" charset="-122"/>
+              <a:cs typeface="Consolas" pitchFamily="34" charset="-120"/>
+            </a:endParaRPr>
           </a:p>
         </p:txBody>
       </p:sp>
@@ -8367,19 +8237,18 @@
             <a:avLst/>
           </a:prstGeom>
           <a:noFill/>
-          <a:ln/>
         </p:spPr>
         <p:txBody>
           <a:bodyPr wrap="square" lIns="0" tIns="0" rIns="0" bIns="0" rtlCol="0" anchor="ctr"/>
           <a:lstStyle/>
           <a:p>
-            <a:pPr indent="0" marL="0">
+            <a:pPr marL="0" indent="0">
               <a:buNone/>
             </a:pPr>
             <a:r>
               <a:rPr lang="en-US" sz="1000" dirty="0">
                 <a:solidFill>
-                  <a:srgbClr val="1A2332"/>
+                  <a:schemeClr val="bg1"/>
                 </a:solidFill>
                 <a:latin typeface="Consolas" pitchFamily="34" charset="0"/>
                 <a:ea typeface="Consolas" pitchFamily="34" charset="-122"/>
@@ -8387,7 +8256,14 @@
               </a:rPr>
               <a:t>feat: add JWT authentication with register and login endpoints</a:t>
             </a:r>
-            <a:endParaRPr lang="en-US" sz="1000" dirty="0"/>
+            <a:endParaRPr lang="en-US" sz="1000" dirty="0">
+              <a:solidFill>
+                <a:schemeClr val="bg1"/>
+              </a:solidFill>
+              <a:latin typeface="Consolas" pitchFamily="34" charset="0"/>
+              <a:ea typeface="Consolas" pitchFamily="34" charset="-122"/>
+              <a:cs typeface="Consolas" pitchFamily="34" charset="-120"/>
+            </a:endParaRPr>
           </a:p>
         </p:txBody>
       </p:sp>
@@ -8456,19 +8332,18 @@
             <a:avLst/>
           </a:prstGeom>
           <a:noFill/>
-          <a:ln/>
         </p:spPr>
         <p:txBody>
           <a:bodyPr wrap="square" lIns="0" tIns="0" rIns="0" bIns="0" rtlCol="0" anchor="ctr"/>
           <a:lstStyle/>
           <a:p>
-            <a:pPr indent="0" marL="0">
+            <a:pPr marL="0" indent="0">
               <a:buNone/>
             </a:pPr>
             <a:r>
               <a:rPr lang="en-US" sz="1000" dirty="0">
                 <a:solidFill>
-                  <a:srgbClr val="1A2332"/>
+                  <a:schemeClr val="bg1"/>
                 </a:solidFill>
                 <a:latin typeface="Consolas" pitchFamily="34" charset="0"/>
                 <a:ea typeface="Consolas" pitchFamily="34" charset="-122"/>
@@ -8476,7 +8351,14 @@
               </a:rPr>
               <a:t>feat: add pytest test suite with 16 passing tests</a:t>
             </a:r>
-            <a:endParaRPr lang="en-US" sz="1000" dirty="0"/>
+            <a:endParaRPr lang="en-US" sz="1000" dirty="0">
+              <a:solidFill>
+                <a:schemeClr val="bg1"/>
+              </a:solidFill>
+              <a:latin typeface="Consolas" pitchFamily="34" charset="0"/>
+              <a:ea typeface="Consolas" pitchFamily="34" charset="-122"/>
+              <a:cs typeface="Consolas" pitchFamily="34" charset="-120"/>
+            </a:endParaRPr>
           </a:p>
         </p:txBody>
       </p:sp>
@@ -8545,19 +8427,18 @@
             <a:avLst/>
           </a:prstGeom>
           <a:noFill/>
-          <a:ln/>
         </p:spPr>
         <p:txBody>
           <a:bodyPr wrap="square" lIns="0" tIns="0" rIns="0" bIns="0" rtlCol="0" anchor="ctr"/>
           <a:lstStyle/>
           <a:p>
-            <a:pPr indent="0" marL="0">
+            <a:pPr marL="0" indent="0">
               <a:buNone/>
             </a:pPr>
             <a:r>
               <a:rPr lang="en-US" sz="1000" dirty="0">
                 <a:solidFill>
-                  <a:srgbClr val="1A2332"/>
+                  <a:schemeClr val="bg1"/>
                 </a:solidFill>
                 <a:latin typeface="Consolas" pitchFamily="34" charset="0"/>
                 <a:ea typeface="Consolas" pitchFamily="34" charset="-122"/>
@@ -8565,7 +8446,14 @@
               </a:rPr>
               <a:t>docs: add API documentation PDF</a:t>
             </a:r>
-            <a:endParaRPr lang="en-US" sz="1000" dirty="0"/>
+            <a:endParaRPr lang="en-US" sz="1000" dirty="0">
+              <a:solidFill>
+                <a:schemeClr val="bg1"/>
+              </a:solidFill>
+              <a:latin typeface="Consolas" pitchFamily="34" charset="0"/>
+              <a:ea typeface="Consolas" pitchFamily="34" charset="-122"/>
+              <a:cs typeface="Consolas" pitchFamily="34" charset="-120"/>
+            </a:endParaRPr>
           </a:p>
         </p:txBody>
       </p:sp>
@@ -8634,19 +8522,18 @@
             <a:avLst/>
           </a:prstGeom>
           <a:noFill/>
-          <a:ln/>
         </p:spPr>
         <p:txBody>
           <a:bodyPr wrap="square" lIns="0" tIns="0" rIns="0" bIns="0" rtlCol="0" anchor="ctr"/>
           <a:lstStyle/>
           <a:p>
-            <a:pPr indent="0" marL="0">
+            <a:pPr marL="0" indent="0">
               <a:buNone/>
             </a:pPr>
             <a:r>
               <a:rPr lang="en-US" sz="1000" dirty="0">
                 <a:solidFill>
-                  <a:srgbClr val="1A2332"/>
+                  <a:schemeClr val="bg1"/>
                 </a:solidFill>
                 <a:latin typeface="Consolas" pitchFamily="34" charset="0"/>
                 <a:ea typeface="Consolas" pitchFamily="34" charset="-122"/>
@@ -8654,7 +8541,14 @@
               </a:rPr>
               <a:t>docs: add technical report PDF</a:t>
             </a:r>
-            <a:endParaRPr lang="en-US" sz="1000" dirty="0"/>
+            <a:endParaRPr lang="en-US" sz="1000" dirty="0">
+              <a:solidFill>
+                <a:schemeClr val="bg1"/>
+              </a:solidFill>
+              <a:latin typeface="Consolas" pitchFamily="34" charset="0"/>
+              <a:ea typeface="Consolas" pitchFamily="34" charset="-122"/>
+              <a:cs typeface="Consolas" pitchFamily="34" charset="-120"/>
+            </a:endParaRPr>
           </a:p>
         </p:txBody>
       </p:sp>
@@ -8668,12 +8562,13 @@
 
 <file path=ppt/slides/slide9.xml><?xml version="1.0" encoding="utf-8"?>
 <p:sld xmlns:a="http://schemas.openxmlformats.org/drawingml/2006/main" xmlns:r="http://schemas.openxmlformats.org/officeDocument/2006/relationships" xmlns:p="http://schemas.openxmlformats.org/presentationml/2006/main">
-  <p:cSld name="Slide 9">
+  <p:cSld>
     <p:bg>
       <p:bgPr>
         <a:solidFill>
           <a:srgbClr val="0F1923"/>
         </a:solidFill>
+        <a:effectLst/>
       </p:bgPr>
     </p:bg>
     <p:spTree>
@@ -8730,13 +8625,12 @@
             <a:avLst/>
           </a:prstGeom>
           <a:noFill/>
-          <a:ln/>
         </p:spPr>
         <p:txBody>
           <a:bodyPr wrap="square" rtlCol="0" anchor="ctr"/>
           <a:lstStyle/>
           <a:p>
-            <a:pPr indent="0" marL="0">
+            <a:pPr marL="0" indent="0">
               <a:buNone/>
             </a:pPr>
             <a:r>
@@ -8794,13 +8688,12 @@
             <a:avLst/>
           </a:prstGeom>
           <a:noFill/>
-          <a:ln/>
         </p:spPr>
         <p:txBody>
           <a:bodyPr wrap="square" lIns="0" tIns="0" rIns="0" bIns="0" rtlCol="0" anchor="ctr"/>
           <a:lstStyle/>
           <a:p>
-            <a:pPr indent="0" marL="0">
+            <a:pPr marL="0" indent="0">
               <a:buNone/>
             </a:pPr>
             <a:r>
@@ -8812,7 +8705,7 @@
                 <a:ea typeface="Calibri" pitchFamily="34" charset="-122"/>
                 <a:cs typeface="Calibri" pitchFamily="34" charset="-120"/>
               </a:rPr>
-              <a:t>Tool: Claude (Anthropic)  |  Target Band: 80–89 (Excellent)</a:t>
+              <a:t>Tool: Claude</a:t>
             </a:r>
             <a:endParaRPr lang="en-US" sz="1300" dirty="0"/>
           </a:p>
@@ -8883,13 +8776,12 @@
             <a:avLst/>
           </a:prstGeom>
           <a:noFill/>
-          <a:ln/>
         </p:spPr>
         <p:txBody>
           <a:bodyPr wrap="square" lIns="0" tIns="0" rIns="0" bIns="0" rtlCol="0" anchor="ctr"/>
           <a:lstStyle/>
           <a:p>
-            <a:pPr indent="0" marL="0">
+            <a:pPr marL="0" indent="0">
               <a:buNone/>
             </a:pPr>
             <a:r>
@@ -8922,19 +8814,18 @@
             <a:avLst/>
           </a:prstGeom>
           <a:noFill/>
-          <a:ln/>
         </p:spPr>
         <p:txBody>
           <a:bodyPr wrap="square" lIns="0" tIns="0" rIns="0" bIns="0" rtlCol="0" anchor="ctr"/>
           <a:lstStyle/>
           <a:p>
-            <a:pPr indent="0" marL="0">
+            <a:pPr marL="0" indent="0">
               <a:buNone/>
             </a:pPr>
             <a:r>
               <a:rPr lang="en-US" sz="1000" dirty="0">
                 <a:solidFill>
-                  <a:srgbClr val="B0BEC5"/>
+                  <a:schemeClr val="bg1"/>
                 </a:solidFill>
                 <a:latin typeface="Calibri" pitchFamily="34" charset="0"/>
                 <a:ea typeface="Calibri" pitchFamily="34" charset="-122"/>
@@ -8942,7 +8833,14 @@
               </a:rPr>
               <a:t>Designed overall project structure, layered architecture, and endpoint organisation before writing code</a:t>
             </a:r>
-            <a:endParaRPr lang="en-US" sz="1000" dirty="0"/>
+            <a:endParaRPr lang="en-US" sz="1000" dirty="0">
+              <a:solidFill>
+                <a:schemeClr val="bg1"/>
+              </a:solidFill>
+              <a:latin typeface="Calibri" pitchFamily="34" charset="0"/>
+              <a:ea typeface="Calibri" pitchFamily="34" charset="-122"/>
+              <a:cs typeface="Calibri" pitchFamily="34" charset="-120"/>
+            </a:endParaRPr>
           </a:p>
         </p:txBody>
       </p:sp>
@@ -8970,6 +8868,12 @@
             <a:prstDash val="solid"/>
           </a:ln>
         </p:spPr>
+        <p:txBody>
+          <a:bodyPr/>
+          <a:p>
+            <a:endParaRPr lang="en-US"/>
+          </a:p>
+        </p:txBody>
       </p:sp>
       <p:sp>
         <p:nvSpPr>
@@ -9011,13 +8915,12 @@
             <a:avLst/>
           </a:prstGeom>
           <a:noFill/>
-          <a:ln/>
         </p:spPr>
         <p:txBody>
           <a:bodyPr wrap="square" lIns="0" tIns="0" rIns="0" bIns="0" rtlCol="0" anchor="ctr"/>
           <a:lstStyle/>
           <a:p>
-            <a:pPr indent="0" marL="0">
+            <a:pPr marL="0" indent="0">
               <a:buNone/>
             </a:pPr>
             <a:r>
@@ -9050,27 +8953,45 @@
             <a:avLst/>
           </a:prstGeom>
           <a:noFill/>
-          <a:ln/>
         </p:spPr>
         <p:txBody>
           <a:bodyPr wrap="square" lIns="0" tIns="0" rIns="0" bIns="0" rtlCol="0" anchor="ctr"/>
           <a:lstStyle/>
           <a:p>
-            <a:pPr indent="0" marL="0">
-              <a:buNone/>
-            </a:pPr>
-            <a:r>
-              <a:rPr lang="en-US" sz="1000" dirty="0">
-                <a:solidFill>
-                  <a:srgbClr val="B0BEC5"/>
-                </a:solidFill>
-                <a:latin typeface="Calibri" pitchFamily="34" charset="0"/>
-                <a:ea typeface="Calibri" pitchFamily="34" charset="-122"/>
-                <a:cs typeface="Calibri" pitchFamily="34" charset="-120"/>
-              </a:rPr>
-              <a:t>Generated models, routers, schemas, recommendation service — all reviewed and tested by author</a:t>
-            </a:r>
-            <a:endParaRPr lang="en-US" sz="1000" dirty="0"/>
+            <a:pPr marL="0" indent="0">
+              <a:buNone/>
+            </a:pPr>
+            <a:r>
+              <a:rPr lang="en-US" altLang="en-US" sz="1000" dirty="0">
+                <a:solidFill>
+                  <a:schemeClr val="bg1"/>
+                </a:solidFill>
+              </a:rPr>
+              <a:t>Partial code generation: Some features that I cannot write were completed with the</a:t>
+            </a:r>
+            <a:endParaRPr lang="en-US" altLang="en-US" sz="1000" dirty="0">
+              <a:solidFill>
+                <a:schemeClr val="bg1"/>
+              </a:solidFill>
+            </a:endParaRPr>
+          </a:p>
+          <a:p>
+            <a:pPr marL="0" indent="0">
+              <a:buNone/>
+            </a:pPr>
+            <a:r>
+              <a:rPr lang="en-US" altLang="en-US" sz="1000" dirty="0">
+                <a:solidFill>
+                  <a:schemeClr val="bg1"/>
+                </a:solidFill>
+              </a:rPr>
+              <a:t>aid of AI</a:t>
+            </a:r>
+            <a:endParaRPr lang="en-US" altLang="en-US" sz="1000" dirty="0">
+              <a:solidFill>
+                <a:schemeClr val="bg1"/>
+              </a:solidFill>
+            </a:endParaRPr>
           </a:p>
         </p:txBody>
       </p:sp>
@@ -9139,13 +9060,12 @@
             <a:avLst/>
           </a:prstGeom>
           <a:noFill/>
-          <a:ln/>
         </p:spPr>
         <p:txBody>
           <a:bodyPr wrap="square" lIns="0" tIns="0" rIns="0" bIns="0" rtlCol="0" anchor="ctr"/>
           <a:lstStyle/>
           <a:p>
-            <a:pPr indent="0" marL="0">
+            <a:pPr marL="0" indent="0">
               <a:buNone/>
             </a:pPr>
             <a:r>
@@ -9178,19 +9098,18 @@
             <a:avLst/>
           </a:prstGeom>
           <a:noFill/>
-          <a:ln/>
         </p:spPr>
         <p:txBody>
           <a:bodyPr wrap="square" lIns="0" tIns="0" rIns="0" bIns="0" rtlCol="0" anchor="ctr"/>
           <a:lstStyle/>
           <a:p>
-            <a:pPr indent="0" marL="0">
+            <a:pPr marL="0" indent="0">
               <a:buNone/>
             </a:pPr>
             <a:r>
               <a:rPr lang="en-US" sz="1000" dirty="0">
                 <a:solidFill>
-                  <a:srgbClr val="B0BEC5"/>
+                  <a:schemeClr val="bg1"/>
                 </a:solidFill>
                 <a:latin typeface="Calibri" pitchFamily="34" charset="0"/>
                 <a:ea typeface="Calibri" pitchFamily="34" charset="-122"/>
@@ -9198,7 +9117,14 @@
               </a:rPr>
               <a:t>Resolved module import failures, bcrypt version conflicts, virtual environment configuration issues</a:t>
             </a:r>
-            <a:endParaRPr lang="en-US" sz="1000" dirty="0"/>
+            <a:endParaRPr lang="en-US" sz="1000" dirty="0">
+              <a:solidFill>
+                <a:schemeClr val="bg1"/>
+              </a:solidFill>
+              <a:latin typeface="Calibri" pitchFamily="34" charset="0"/>
+              <a:ea typeface="Calibri" pitchFamily="34" charset="-122"/>
+              <a:cs typeface="Calibri" pitchFamily="34" charset="-120"/>
+            </a:endParaRPr>
           </a:p>
         </p:txBody>
       </p:sp>
@@ -9267,13 +9193,12 @@
             <a:avLst/>
           </a:prstGeom>
           <a:noFill/>
-          <a:ln/>
         </p:spPr>
         <p:txBody>
           <a:bodyPr wrap="square" lIns="0" tIns="0" rIns="0" bIns="0" rtlCol="0" anchor="ctr"/>
           <a:lstStyle/>
           <a:p>
-            <a:pPr indent="0" marL="0">
+            <a:pPr marL="0" indent="0">
               <a:buNone/>
             </a:pPr>
             <a:r>
@@ -9306,19 +9231,18 @@
             <a:avLst/>
           </a:prstGeom>
           <a:noFill/>
-          <a:ln/>
         </p:spPr>
         <p:txBody>
           <a:bodyPr wrap="square" lIns="0" tIns="0" rIns="0" bIns="0" rtlCol="0" anchor="ctr"/>
           <a:lstStyle/>
           <a:p>
-            <a:pPr indent="0" marL="0">
+            <a:pPr marL="0" indent="0">
               <a:buNone/>
             </a:pPr>
             <a:r>
               <a:rPr lang="en-US" sz="1000" dirty="0">
                 <a:solidFill>
-                  <a:srgbClr val="B0BEC5"/>
+                  <a:schemeClr val="bg1"/>
                 </a:solidFill>
                 <a:latin typeface="Calibri" pitchFamily="34" charset="0"/>
                 <a:ea typeface="Calibri" pitchFamily="34" charset="-122"/>
@@ -9326,7 +9250,14 @@
               </a:rPr>
               <a:t>Suggested Spotify Tracks Dataset and generated bulk CSV import script</a:t>
             </a:r>
-            <a:endParaRPr lang="en-US" sz="1000" dirty="0"/>
+            <a:endParaRPr lang="en-US" sz="1000" dirty="0">
+              <a:solidFill>
+                <a:schemeClr val="bg1"/>
+              </a:solidFill>
+              <a:latin typeface="Calibri" pitchFamily="34" charset="0"/>
+              <a:ea typeface="Calibri" pitchFamily="34" charset="-122"/>
+              <a:cs typeface="Calibri" pitchFamily="34" charset="-120"/>
+            </a:endParaRPr>
           </a:p>
         </p:txBody>
       </p:sp>
@@ -9395,13 +9326,12 @@
             <a:avLst/>
           </a:prstGeom>
           <a:noFill/>
-          <a:ln/>
         </p:spPr>
         <p:txBody>
           <a:bodyPr wrap="square" lIns="0" tIns="0" rIns="0" bIns="0" rtlCol="0" anchor="ctr"/>
           <a:lstStyle/>
           <a:p>
-            <a:pPr indent="0" marL="0">
+            <a:pPr marL="0" indent="0">
               <a:buNone/>
             </a:pPr>
             <a:r>
@@ -9434,27 +9364,27 @@
             <a:avLst/>
           </a:prstGeom>
           <a:noFill/>
-          <a:ln/>
         </p:spPr>
         <p:txBody>
           <a:bodyPr wrap="square" lIns="0" tIns="0" rIns="0" bIns="0" rtlCol="0" anchor="ctr"/>
           <a:lstStyle/>
           <a:p>
-            <a:pPr indent="0" marL="0">
-              <a:buNone/>
-            </a:pPr>
-            <a:r>
-              <a:rPr lang="en-US" sz="1000" dirty="0">
-                <a:solidFill>
-                  <a:srgbClr val="B0BEC5"/>
-                </a:solidFill>
-                <a:latin typeface="Calibri" pitchFamily="34" charset="0"/>
-                <a:ea typeface="Calibri" pitchFamily="34" charset="-122"/>
-                <a:cs typeface="Calibri" pitchFamily="34" charset="-120"/>
-              </a:rPr>
-              <a:t>Drafted technical report framework; content reflects author's actual design decisions</a:t>
-            </a:r>
-            <a:endParaRPr lang="en-US" sz="1000" dirty="0"/>
+            <a:pPr marL="0" indent="0">
+              <a:buNone/>
+            </a:pPr>
+            <a:r>
+              <a:rPr lang="en-US" altLang="en-US" sz="1000" dirty="0">
+                <a:solidFill>
+                  <a:schemeClr val="bg1"/>
+                </a:solidFill>
+              </a:rPr>
+              <a:t>Constructing a report framework</a:t>
+            </a:r>
+            <a:endParaRPr lang="en-US" altLang="en-US" sz="1000" dirty="0">
+              <a:solidFill>
+                <a:schemeClr val="bg1"/>
+              </a:solidFill>
+            </a:endParaRPr>
           </a:p>
         </p:txBody>
       </p:sp>
@@ -9509,7 +9439,7 @@
     </a:clrScheme>
     <a:fontScheme name="Office">
       <a:majorFont>
-        <a:latin typeface="Calibri Light" panose="020F0302020204030204"/>
+        <a:latin typeface="Calibri Light"/>
         <a:ea typeface=""/>
         <a:cs typeface=""/>
         <a:font script="Jpan" typeface="游ゴシック Light"/>
@@ -9542,26 +9472,9 @@
         <a:font script="Viet" typeface="Times New Roman"/>
         <a:font script="Uigh" typeface="Microsoft Uighur"/>
         <a:font script="Geor" typeface="Sylfaen"/>
-        <a:font script="Armn" typeface="Arial"/>
-        <a:font script="Bugi" typeface="Leelawadee UI"/>
-        <a:font script="Bopo" typeface="Microsoft JhengHei"/>
-        <a:font script="Java" typeface="Javanese Text"/>
-        <a:font script="Lisu" typeface="Segoe UI"/>
-        <a:font script="Mymr" typeface="Myanmar Text"/>
-        <a:font script="Nkoo" typeface="Ebrima"/>
-        <a:font script="Olck" typeface="Nirmala UI"/>
-        <a:font script="Osma" typeface="Ebrima"/>
-        <a:font script="Phag" typeface="Phagspa"/>
-        <a:font script="Syrn" typeface="Estrangelo Edessa"/>
-        <a:font script="Syrj" typeface="Estrangelo Edessa"/>
-        <a:font script="Syre" typeface="Estrangelo Edessa"/>
-        <a:font script="Sora" typeface="Nirmala UI"/>
-        <a:font script="Tale" typeface="Microsoft Tai Le"/>
-        <a:font script="Talu" typeface="Microsoft New Tai Lue"/>
-        <a:font script="Tfng" typeface="Ebrima"/>
       </a:majorFont>
       <a:minorFont>
-        <a:latin typeface="Calibri" panose="020F0502020204030204"/>
+        <a:latin typeface="Calibri"/>
         <a:ea typeface=""/>
         <a:cs typeface=""/>
         <a:font script="Jpan" typeface="游ゴシック"/>
@@ -9594,23 +9507,6 @@
         <a:font script="Viet" typeface="Arial"/>
         <a:font script="Uigh" typeface="Microsoft Uighur"/>
         <a:font script="Geor" typeface="Sylfaen"/>
-        <a:font script="Armn" typeface="Arial"/>
-        <a:font script="Bugi" typeface="Leelawadee UI"/>
-        <a:font script="Bopo" typeface="Microsoft JhengHei"/>
-        <a:font script="Java" typeface="Javanese Text"/>
-        <a:font script="Lisu" typeface="Segoe UI"/>
-        <a:font script="Mymr" typeface="Myanmar Text"/>
-        <a:font script="Nkoo" typeface="Ebrima"/>
-        <a:font script="Olck" typeface="Nirmala UI"/>
-        <a:font script="Osma" typeface="Ebrima"/>
-        <a:font script="Phag" typeface="Phagspa"/>
-        <a:font script="Syrn" typeface="Estrangelo Edessa"/>
-        <a:font script="Syrj" typeface="Estrangelo Edessa"/>
-        <a:font script="Syre" typeface="Estrangelo Edessa"/>
-        <a:font script="Sora" typeface="Nirmala UI"/>
-        <a:font script="Tale" typeface="Microsoft Tai Le"/>
-        <a:font script="Talu" typeface="Microsoft New Tai Lue"/>
-        <a:font script="Tfng" typeface="Ebrima"/>
       </a:minorFont>
     </a:fontScheme>
     <a:fmtScheme name="Office">
@@ -9751,8 +9647,265 @@
       </a:bgFillStyleLst>
     </a:fmtScheme>
   </a:themeElements>
-  <a:objectDefaults/>
-  <a:extraClrSchemeLst/>
+  <a:extLst>
+    <a:ext uri="{05A4C25C-085E-4340-85A3-A5531E510DB2}">
+      <thm15:themeFamily xmlns:thm15="http://schemas.microsoft.com/office/thememl/2012/main" name="Office Theme" id="{62F939B6-93AF-4DB8-9C6B-D6C7DFDC589F}" vid="{4A3C46E8-61CC-4603-A589-7422A47A8E4A}"/>
+    </a:ext>
+  </a:extLst>
+</a:theme>
+</file>
+
+<file path=ppt/theme/theme2.xml><?xml version="1.0" encoding="utf-8"?>
+<a:theme xmlns:a="http://schemas.openxmlformats.org/drawingml/2006/main" name="Office Theme">
+  <a:themeElements>
+    <a:clrScheme name="Office">
+      <a:dk1>
+        <a:sysClr val="windowText" lastClr="000000"/>
+      </a:dk1>
+      <a:lt1>
+        <a:sysClr val="window" lastClr="FFFFFF"/>
+      </a:lt1>
+      <a:dk2>
+        <a:srgbClr val="44546A"/>
+      </a:dk2>
+      <a:lt2>
+        <a:srgbClr val="E7E6E6"/>
+      </a:lt2>
+      <a:accent1>
+        <a:srgbClr val="4472C4"/>
+      </a:accent1>
+      <a:accent2>
+        <a:srgbClr val="ED7D31"/>
+      </a:accent2>
+      <a:accent3>
+        <a:srgbClr val="A5A5A5"/>
+      </a:accent3>
+      <a:accent4>
+        <a:srgbClr val="FFC000"/>
+      </a:accent4>
+      <a:accent5>
+        <a:srgbClr val="5B9BD5"/>
+      </a:accent5>
+      <a:accent6>
+        <a:srgbClr val="70AD47"/>
+      </a:accent6>
+      <a:hlink>
+        <a:srgbClr val="0563C1"/>
+      </a:hlink>
+      <a:folHlink>
+        <a:srgbClr val="954F72"/>
+      </a:folHlink>
+    </a:clrScheme>
+    <a:fontScheme name="Office">
+      <a:majorFont>
+        <a:latin typeface="Calibri Light"/>
+        <a:ea typeface=""/>
+        <a:cs typeface=""/>
+        <a:font script="Jpan" typeface="游ゴシック Light"/>
+        <a:font script="Hang" typeface="맑은 고딕"/>
+        <a:font script="Hans" typeface="等线 Light"/>
+        <a:font script="Hant" typeface="新細明體"/>
+        <a:font script="Arab" typeface="Times New Roman"/>
+        <a:font script="Hebr" typeface="Times New Roman"/>
+        <a:font script="Thai" typeface="Angsana New"/>
+        <a:font script="Ethi" typeface="Nyala"/>
+        <a:font script="Beng" typeface="Vrinda"/>
+        <a:font script="Gujr" typeface="Shruti"/>
+        <a:font script="Khmr" typeface="MoolBoran"/>
+        <a:font script="Knda" typeface="Tunga"/>
+        <a:font script="Guru" typeface="Raavi"/>
+        <a:font script="Cans" typeface="Euphemia"/>
+        <a:font script="Cher" typeface="Plantagenet Cherokee"/>
+        <a:font script="Yiii" typeface="Microsoft Yi Baiti"/>
+        <a:font script="Tibt" typeface="Microsoft Himalaya"/>
+        <a:font script="Thaa" typeface="MV Boli"/>
+        <a:font script="Deva" typeface="Mangal"/>
+        <a:font script="Telu" typeface="Gautami"/>
+        <a:font script="Taml" typeface="Latha"/>
+        <a:font script="Syrc" typeface="Estrangelo Edessa"/>
+        <a:font script="Orya" typeface="Kalinga"/>
+        <a:font script="Mlym" typeface="Kartika"/>
+        <a:font script="Laoo" typeface="DokChampa"/>
+        <a:font script="Sinh" typeface="Iskoola Pota"/>
+        <a:font script="Mong" typeface="Mongolian Baiti"/>
+        <a:font script="Viet" typeface="Times New Roman"/>
+        <a:font script="Uigh" typeface="Microsoft Uighur"/>
+        <a:font script="Geor" typeface="Sylfaen"/>
+      </a:majorFont>
+      <a:minorFont>
+        <a:latin typeface="Calibri"/>
+        <a:ea typeface=""/>
+        <a:cs typeface=""/>
+        <a:font script="Jpan" typeface="游ゴシック"/>
+        <a:font script="Hang" typeface="맑은 고딕"/>
+        <a:font script="Hans" typeface="等线"/>
+        <a:font script="Hant" typeface="新細明體"/>
+        <a:font script="Arab" typeface="Arial"/>
+        <a:font script="Hebr" typeface="Arial"/>
+        <a:font script="Thai" typeface="Cordia New"/>
+        <a:font script="Ethi" typeface="Nyala"/>
+        <a:font script="Beng" typeface="Vrinda"/>
+        <a:font script="Gujr" typeface="Shruti"/>
+        <a:font script="Khmr" typeface="DaunPenh"/>
+        <a:font script="Knda" typeface="Tunga"/>
+        <a:font script="Guru" typeface="Raavi"/>
+        <a:font script="Cans" typeface="Euphemia"/>
+        <a:font script="Cher" typeface="Plantagenet Cherokee"/>
+        <a:font script="Yiii" typeface="Microsoft Yi Baiti"/>
+        <a:font script="Tibt" typeface="Microsoft Himalaya"/>
+        <a:font script="Thaa" typeface="MV Boli"/>
+        <a:font script="Deva" typeface="Mangal"/>
+        <a:font script="Telu" typeface="Gautami"/>
+        <a:font script="Taml" typeface="Latha"/>
+        <a:font script="Syrc" typeface="Estrangelo Edessa"/>
+        <a:font script="Orya" typeface="Kalinga"/>
+        <a:font script="Mlym" typeface="Kartika"/>
+        <a:font script="Laoo" typeface="DokChampa"/>
+        <a:font script="Sinh" typeface="Iskoola Pota"/>
+        <a:font script="Mong" typeface="Mongolian Baiti"/>
+        <a:font script="Viet" typeface="Arial"/>
+        <a:font script="Uigh" typeface="Microsoft Uighur"/>
+        <a:font script="Geor" typeface="Sylfaen"/>
+      </a:minorFont>
+    </a:fontScheme>
+    <a:fmtScheme name="Office">
+      <a:fillStyleLst>
+        <a:solidFill>
+          <a:schemeClr val="phClr"/>
+        </a:solidFill>
+        <a:gradFill rotWithShape="1">
+          <a:gsLst>
+            <a:gs pos="0">
+              <a:schemeClr val="phClr">
+                <a:lumMod val="110000"/>
+                <a:satMod val="105000"/>
+                <a:tint val="67000"/>
+              </a:schemeClr>
+            </a:gs>
+            <a:gs pos="50000">
+              <a:schemeClr val="phClr">
+                <a:lumMod val="105000"/>
+                <a:satMod val="103000"/>
+                <a:tint val="73000"/>
+              </a:schemeClr>
+            </a:gs>
+            <a:gs pos="100000">
+              <a:schemeClr val="phClr">
+                <a:lumMod val="105000"/>
+                <a:satMod val="109000"/>
+                <a:tint val="81000"/>
+              </a:schemeClr>
+            </a:gs>
+          </a:gsLst>
+          <a:lin ang="5400000" scaled="0"/>
+        </a:gradFill>
+        <a:gradFill rotWithShape="1">
+          <a:gsLst>
+            <a:gs pos="0">
+              <a:schemeClr val="phClr">
+                <a:satMod val="103000"/>
+                <a:lumMod val="102000"/>
+                <a:tint val="94000"/>
+              </a:schemeClr>
+            </a:gs>
+            <a:gs pos="50000">
+              <a:schemeClr val="phClr">
+                <a:satMod val="110000"/>
+                <a:lumMod val="100000"/>
+                <a:shade val="100000"/>
+              </a:schemeClr>
+            </a:gs>
+            <a:gs pos="100000">
+              <a:schemeClr val="phClr">
+                <a:lumMod val="99000"/>
+                <a:satMod val="120000"/>
+                <a:shade val="78000"/>
+              </a:schemeClr>
+            </a:gs>
+          </a:gsLst>
+          <a:lin ang="5400000" scaled="0"/>
+        </a:gradFill>
+      </a:fillStyleLst>
+      <a:lnStyleLst>
+        <a:ln w="6350" cap="flat" cmpd="sng" algn="ctr">
+          <a:solidFill>
+            <a:schemeClr val="phClr"/>
+          </a:solidFill>
+          <a:prstDash val="solid"/>
+          <a:miter lim="800000"/>
+        </a:ln>
+        <a:ln w="12700" cap="flat" cmpd="sng" algn="ctr">
+          <a:solidFill>
+            <a:schemeClr val="phClr"/>
+          </a:solidFill>
+          <a:prstDash val="solid"/>
+          <a:miter lim="800000"/>
+        </a:ln>
+        <a:ln w="19050" cap="flat" cmpd="sng" algn="ctr">
+          <a:solidFill>
+            <a:schemeClr val="phClr"/>
+          </a:solidFill>
+          <a:prstDash val="solid"/>
+          <a:miter lim="800000"/>
+        </a:ln>
+      </a:lnStyleLst>
+      <a:effectStyleLst>
+        <a:effectStyle>
+          <a:effectLst/>
+        </a:effectStyle>
+        <a:effectStyle>
+          <a:effectLst/>
+        </a:effectStyle>
+        <a:effectStyle>
+          <a:effectLst>
+            <a:outerShdw blurRad="57150" dist="19050" dir="5400000" algn="ctr" rotWithShape="0">
+              <a:srgbClr val="000000">
+                <a:alpha val="63000"/>
+              </a:srgbClr>
+            </a:outerShdw>
+          </a:effectLst>
+        </a:effectStyle>
+      </a:effectStyleLst>
+      <a:bgFillStyleLst>
+        <a:solidFill>
+          <a:schemeClr val="phClr"/>
+        </a:solidFill>
+        <a:solidFill>
+          <a:schemeClr val="phClr">
+            <a:tint val="95000"/>
+            <a:satMod val="170000"/>
+          </a:schemeClr>
+        </a:solidFill>
+        <a:gradFill rotWithShape="1">
+          <a:gsLst>
+            <a:gs pos="0">
+              <a:schemeClr val="phClr">
+                <a:tint val="93000"/>
+                <a:satMod val="150000"/>
+                <a:shade val="98000"/>
+                <a:lumMod val="102000"/>
+              </a:schemeClr>
+            </a:gs>
+            <a:gs pos="50000">
+              <a:schemeClr val="phClr">
+                <a:tint val="98000"/>
+                <a:satMod val="130000"/>
+                <a:shade val="90000"/>
+                <a:lumMod val="103000"/>
+              </a:schemeClr>
+            </a:gs>
+            <a:gs pos="100000">
+              <a:schemeClr val="phClr">
+                <a:shade val="63000"/>
+                <a:satMod val="120000"/>
+              </a:schemeClr>
+            </a:gs>
+          </a:gsLst>
+          <a:lin ang="5400000" scaled="0"/>
+        </a:gradFill>
+      </a:bgFillStyleLst>
+    </a:fmtScheme>
+  </a:themeElements>
   <a:extLst>
     <a:ext uri="{05A4C25C-085E-4340-85A3-A5531E510DB2}">
       <thm15:themeFamily xmlns:thm15="http://schemas.microsoft.com/office/thememl/2012/main" name="Office Theme" id="{62F939B6-93AF-4DB8-9C6B-D6C7DFDC589F}" vid="{4A3C46E8-61CC-4603-A589-7422A47A8E4A}"/>

</xml_diff>